<commit_message>
walk deck F15/F16: the unguided experiment's measured FAIL, folded in
Slide F15 now presents the result instead of a pending line, parsed
from the committed t5_unguided_REPORT.md: verdict, the three-attempt
table (every crash the same optical condition -- an offset field losing
all rays -- surfacing as an unhandled empty/NaN in a figure helper),
the root cause in the packet's own words (S1 solves far past the
source rung and the documented S2 mechanism goes past traceability;
named, unguarded), the act-first frictions (F7 one-point headline, F8
the 1e9-sentinel start, F1/F2 doc-path gaps, F3/F4 undocumented
load-bearing knobs, F13 the 25-field lesson never reaching defaults),
and the two negatives that worked.  F16 gains the empirical anchor:
docs + gates as committed did NOT carry an unassisted user -- and both
camps claim it (the one conceptual failure argues for call-time
advice; 13 of 15 frictions compile into checks).

Co-Authored-By: Claude Fable 5 <noreply@anthropic.com>
</commit_message>
<xml_diff>
--- a/mmacos/challenges/rodgers3/deck_rodgers3_walk.pptx
+++ b/mmacos/challenges/rodgers3/deck_rodgers3_walk.pptx
@@ -6093,7 +6093,7 @@
                 </a:solidFill>
                 <a:latin typeface="Arial"/>
               </a:rPr>
-              <a:t>The experiment is running; its protocol is the point</a:t>
+              <a:t>Measured: FAIL — three attempts, three crashes, none past stage 2 of 5</a:t>
             </a:r>
           </a:p>
         </p:txBody>
@@ -6176,69 +6176,409 @@
                 </a:solidFill>
                 <a:latin typeface="Arial"/>
               </a:rPr>
-              <a:t>•  The claim under test: "a re-do at different parameters is ONE CALL."  The instrument: an agent restricted to the COMMITTED docs only (README, packet + addendum, function help) — no lore files, no memory, no fixes allowed — plays the new-user proxy at a fresh instance: EPD 150 mm, F/3.3, 15°x15° at 22.5°, clearances &gt; 40 / &gt; 25 mm, exit horizontal.</a:t>
-            </a:r>
-          </a:p>
-          <a:p>
-            <a:pPr>
-              <a:spcAft>
-                <a:spcPts val="600"/>
-              </a:spcAft>
-            </a:pPr>
-            <a:r>
-              <a:rPr sz="1200" b="0">
-                <a:solidFill>
-                  <a:srgbClr val="282828"/>
-                </a:solidFill>
-                <a:latin typeface="Arial"/>
-              </a:rPr>
-              <a:t>•  The PACKAGING ENVELOPE is deliberately left to the docs: whether a documented feasibility screen (the field-walk rule, addendum SSC) gets found and applied is part of the measurement.</a:t>
-            </a:r>
-          </a:p>
-          <a:p>
-            <a:pPr>
-              <a:spcAft>
-                <a:spcPts val="600"/>
-              </a:spcAft>
-            </a:pPr>
-            <a:r>
-              <a:rPr sz="1200" b="0">
-                <a:solidFill>
-                  <a:srgbClr val="282828"/>
-                </a:solidFill>
-                <a:latin typeface="Arial"/>
-              </a:rPr>
-              <a:t>•  The deliverable either way: a verdict plus a verbatim FRICTION LIST — every silence, wrong turn, and guess.  A negative result is a valid result.</a:t>
-            </a:r>
-          </a:p>
-          <a:p>
-            <a:pPr>
-              <a:spcAft>
-                <a:spcPts val="600"/>
-              </a:spcAft>
-            </a:pPr>
-            <a:r>
-              <a:rPr sz="1200" b="0">
-                <a:solidFill>
-                  <a:srgbClr val="282828"/>
-                </a:solidFill>
-                <a:latin typeface="Arial"/>
-              </a:rPr>
-              <a:t>•  Result: PENDING -- the run is in progress; this slide updates itself from t5_unguided_REPORT.md at the next build.</a:t>
-            </a:r>
-          </a:p>
-        </p:txBody>
-      </p:sp>
-      <p:sp>
-        <p:nvSpPr>
-          <p:cNvPr id="5" name="TextBox 4"/>
+              <a:t>•  The protocol: an agent restricted to the COMMITTED docs (README, packet + addendum, function help) — no lore, no memory, no fixes — plays the new-user proxy at a fresh instance (EPD 150 mm, F/3.3, 15°x15° at 22.5°, clearances &gt; 40 / &gt; 25 mm, exit horizontal), envelope and seed left to the docs.</a:t>
+            </a:r>
+          </a:p>
+        </p:txBody>
+      </p:sp>
+      <p:graphicFrame>
+        <p:nvGraphicFramePr>
+          <p:cNvPr id="5" name="Table 4"/>
+          <p:cNvGraphicFramePr>
+            <a:graphicFrameLocks noGrp="1"/>
+          </p:cNvGraphicFramePr>
+          <p:nvPr/>
+        </p:nvGraphicFramePr>
+        <p:xfrm>
+          <a:off x="411480" y="2267712"/>
+          <a:ext cx="5806438" cy="1685925"/>
+        </p:xfrm>
+        <a:graphic>
+          <a:graphicData uri="http://schemas.openxmlformats.org/drawingml/2006/table">
+            <a:tbl>
+              <a:tblPr firstRow="1" bandRow="1">
+                <a:tableStyleId>{5C22544A-7EE6-4342-B048-85BDC9FD1C3A}</a:tableStyleId>
+              </a:tblPr>
+              <a:tblGrid>
+                <a:gridCol w="456686"/>
+                <a:gridCol w="3457767"/>
+                <a:gridCol w="782890"/>
+                <a:gridCol w="1109095"/>
+              </a:tblGrid>
+              <a:tr h="280035">
+                <a:tc>
+                  <a:txBody>
+                    <a:bodyPr wrap="square"/>
+                    <a:lstStyle/>
+                    <a:p>
+                      <a:r>
+                        <a:rPr sz="1100" b="1">
+                          <a:solidFill>
+                            <a:srgbClr val="FFFFFF"/>
+                          </a:solidFill>
+                          <a:latin typeface="Arial"/>
+                        </a:rPr>
+                        <a:t>attempt</a:t>
+                      </a:r>
+                    </a:p>
+                  </a:txBody>
+                  <a:tcPr marL="54864" marR="54864" marT="18288" marB="18288">
+                    <a:solidFill>
+                      <a:srgbClr val="1F4E79"/>
+                    </a:solidFill>
+                  </a:tcPr>
+                </a:tc>
+                <a:tc>
+                  <a:txBody>
+                    <a:bodyPr wrap="square"/>
+                    <a:lstStyle/>
+                    <a:p>
+                      <a:r>
+                        <a:rPr sz="1100" b="1">
+                          <a:solidFill>
+                            <a:srgbClr val="FFFFFF"/>
+                          </a:solidFill>
+                          <a:latin typeface="Arial"/>
+                        </a:rPr>
+                        <a:t>envelope</a:t>
+                      </a:r>
+                    </a:p>
+                  </a:txBody>
+                  <a:tcPr marL="54864" marR="54864" marT="18288" marB="18288">
+                    <a:solidFill>
+                      <a:srgbClr val="1F4E79"/>
+                    </a:solidFill>
+                  </a:tcPr>
+                </a:tc>
+                <a:tc>
+                  <a:txBody>
+                    <a:bodyPr wrap="square"/>
+                    <a:lstStyle/>
+                    <a:p>
+                      <a:r>
+                        <a:rPr sz="1100" b="1">
+                          <a:solidFill>
+                            <a:srgbClr val="FFFFFF"/>
+                          </a:solidFill>
+                          <a:latin typeface="Arial"/>
+                        </a:rPr>
+                        <a:t>reached</a:t>
+                      </a:r>
+                    </a:p>
+                  </a:txBody>
+                  <a:tcPr marL="54864" marR="54864" marT="18288" marB="18288">
+                    <a:solidFill>
+                      <a:srgbClr val="1F4E79"/>
+                    </a:solidFill>
+                  </a:tcPr>
+                </a:tc>
+                <a:tc>
+                  <a:txBody>
+                    <a:bodyPr wrap="square"/>
+                    <a:lstStyle/>
+                    <a:p>
+                      <a:r>
+                        <a:rPr sz="1100" b="1">
+                          <a:solidFill>
+                            <a:srgbClr val="FFFFFF"/>
+                          </a:solidFill>
+                          <a:latin typeface="Arial"/>
+                        </a:rPr>
+                        <a:t>died in</a:t>
+                      </a:r>
+                    </a:p>
+                  </a:txBody>
+                  <a:tcPr marL="54864" marR="54864" marT="18288" marB="18288">
+                    <a:solidFill>
+                      <a:srgbClr val="1F4E79"/>
+                    </a:solidFill>
+                  </a:tcPr>
+                </a:tc>
+              </a:tr>
+              <a:tr h="468630">
+                <a:tc>
+                  <a:txBody>
+                    <a:bodyPr wrap="square"/>
+                    <a:lstStyle/>
+                    <a:p>
+                      <a:r>
+                        <a:rPr sz="1100" b="0">
+                          <a:solidFill>
+                            <a:srgbClr val="282828"/>
+                          </a:solidFill>
+                          <a:latin typeface="Arial"/>
+                        </a:rPr>
+                        <a:t>1</a:t>
+                      </a:r>
+                    </a:p>
+                  </a:txBody>
+                  <a:tcPr marL="54864" marR="54864" marT="18288" marB="18288">
+                    <a:solidFill>
+                      <a:srgbClr val="FFFFFF"/>
+                    </a:solidFill>
+                  </a:tcPr>
+                </a:tc>
+                <a:tc>
+                  <a:txBody>
+                    <a:bodyPr wrap="square"/>
+                    <a:lstStyle/>
+                    <a:p>
+                      <a:r>
+                        <a:rPr sz="1100" b="0">
+                          <a:solidFill>
+                            <a:srgbClr val="282828"/>
+                          </a:solidFill>
+                          <a:latin typeface="Arial"/>
+                        </a:rPr>
+                        <a:t>2× rodgers3 (EPD ratio)</a:t>
+                      </a:r>
+                    </a:p>
+                  </a:txBody>
+                  <a:tcPr marL="54864" marR="54864" marT="18288" marB="18288">
+                    <a:solidFill>
+                      <a:srgbClr val="FFFFFF"/>
+                    </a:solidFill>
+                  </a:tcPr>
+                </a:tc>
+                <a:tc>
+                  <a:txBody>
+                    <a:bodyPr wrap="square"/>
+                    <a:lstStyle/>
+                    <a:p>
+                      <a:r>
+                        <a:rPr sz="1100" b="0">
+                          <a:solidFill>
+                            <a:srgbClr val="282828"/>
+                          </a:solidFill>
+                          <a:latin typeface="Arial"/>
+                        </a:rPr>
+                        <a:t>S1 (20.9 nm)</a:t>
+                      </a:r>
+                    </a:p>
+                  </a:txBody>
+                  <a:tcPr marL="54864" marR="54864" marT="18288" marB="18288">
+                    <a:solidFill>
+                      <a:srgbClr val="FFFFFF"/>
+                    </a:solidFill>
+                  </a:tcPr>
+                </a:tc>
+                <a:tc>
+                  <a:txBody>
+                    <a:bodyPr wrap="square"/>
+                    <a:lstStyle/>
+                    <a:p>
+                      <a:r>
+                        <a:rPr sz="1100" b="0">
+                          <a:solidFill>
+                            <a:srgbClr val="282828"/>
+                          </a:solidFill>
+                          <a:latin typeface="Arial"/>
+                        </a:rPr>
+                        <a:t>oi_map_fig:43</a:t>
+                      </a:r>
+                    </a:p>
+                  </a:txBody>
+                  <a:tcPr marL="54864" marR="54864" marT="18288" marB="18288">
+                    <a:solidFill>
+                      <a:srgbClr val="FFFFFF"/>
+                    </a:solidFill>
+                  </a:tcPr>
+                </a:tc>
+              </a:tr>
+              <a:tr h="468630">
+                <a:tc>
+                  <a:txBody>
+                    <a:bodyPr wrap="square"/>
+                    <a:lstStyle/>
+                    <a:p>
+                      <a:r>
+                        <a:rPr sz="1100" b="0">
+                          <a:solidFill>
+                            <a:srgbClr val="282828"/>
+                          </a:solidFill>
+                          <a:latin typeface="Arial"/>
+                        </a:rPr>
+                        <a:t>2</a:t>
+                      </a:r>
+                    </a:p>
+                  </a:txBody>
+                  <a:tcPr marL="54864" marR="54864" marT="18288" marB="18288">
+                    <a:solidFill>
+                      <a:srgbClr val="ECF1F6"/>
+                    </a:solidFill>
+                  </a:tcPr>
+                </a:tc>
+                <a:tc>
+                  <a:txBody>
+                    <a:bodyPr wrap="square"/>
+                    <a:lstStyle/>
+                    <a:p>
+                      <a:r>
+                        <a:rPr sz="1100" b="0">
+                          <a:solidFill>
+                            <a:srgbClr val="282828"/>
+                          </a:solidFill>
+                          <a:latin typeface="Arial"/>
+                        </a:rPr>
+                        <a:t>1.65× rodgers3 (EFL ratio, the rescale the docs name)</a:t>
+                      </a:r>
+                    </a:p>
+                  </a:txBody>
+                  <a:tcPr marL="54864" marR="54864" marT="18288" marB="18288">
+                    <a:solidFill>
+                      <a:srgbClr val="ECF1F6"/>
+                    </a:solidFill>
+                  </a:tcPr>
+                </a:tc>
+                <a:tc>
+                  <a:txBody>
+                    <a:bodyPr wrap="square"/>
+                    <a:lstStyle/>
+                    <a:p>
+                      <a:r>
+                        <a:rPr sz="1100" b="0">
+                          <a:solidFill>
+                            <a:srgbClr val="282828"/>
+                          </a:solidFill>
+                          <a:latin typeface="Arial"/>
+                        </a:rPr>
+                        <a:t>S1 (30.6 nm)</a:t>
+                      </a:r>
+                    </a:p>
+                  </a:txBody>
+                  <a:tcPr marL="54864" marR="54864" marT="18288" marB="18288">
+                    <a:solidFill>
+                      <a:srgbClr val="ECF1F6"/>
+                    </a:solidFill>
+                  </a:tcPr>
+                </a:tc>
+                <a:tc>
+                  <a:txBody>
+                    <a:bodyPr wrap="square"/>
+                    <a:lstStyle/>
+                    <a:p>
+                      <a:r>
+                        <a:rPr sz="1100" b="0">
+                          <a:solidFill>
+                            <a:srgbClr val="282828"/>
+                          </a:solidFill>
+                          <a:latin typeface="Arial"/>
+                        </a:rPr>
+                        <a:t>oi_layout_fig:140</a:t>
+                      </a:r>
+                    </a:p>
+                  </a:txBody>
+                  <a:tcPr marL="54864" marR="54864" marT="18288" marB="18288">
+                    <a:solidFill>
+                      <a:srgbClr val="ECF1F6"/>
+                    </a:solidFill>
+                  </a:tcPr>
+                </a:tc>
+              </a:tr>
+              <a:tr h="468630">
+                <a:tc>
+                  <a:txBody>
+                    <a:bodyPr wrap="square"/>
+                    <a:lstStyle/>
+                    <a:p>
+                      <a:r>
+                        <a:rPr sz="1100" b="0">
+                          <a:solidFill>
+                            <a:srgbClr val="282828"/>
+                          </a:solidFill>
+                          <a:latin typeface="Arial"/>
+                        </a:rPr>
+                        <a:t>3</a:t>
+                      </a:r>
+                    </a:p>
+                  </a:txBody>
+                  <a:tcPr marL="54864" marR="54864" marT="18288" marB="18288">
+                    <a:solidFill>
+                      <a:srgbClr val="FFFFFF"/>
+                    </a:solidFill>
+                  </a:tcPr>
+                </a:tc>
+                <a:tc>
+                  <a:txBody>
+                    <a:bodyPr wrap="square"/>
+                    <a:lstStyle/>
+                    <a:p>
+                      <a:r>
+                        <a:rPr sz="1100" b="0">
+                          <a:solidFill>
+                            <a:srgbClr val="282828"/>
+                          </a:solidFill>
+                          <a:latin typeface="Arial"/>
+                        </a:rPr>
+                        <a:t>as attempt 2, stages=[1 3 4 5] (documented S2 skip)</a:t>
+                      </a:r>
+                    </a:p>
+                  </a:txBody>
+                  <a:tcPr marL="54864" marR="54864" marT="18288" marB="18288">
+                    <a:solidFill>
+                      <a:srgbClr val="FFFFFF"/>
+                    </a:solidFill>
+                  </a:tcPr>
+                </a:tc>
+                <a:tc>
+                  <a:txBody>
+                    <a:bodyPr wrap="square"/>
+                    <a:lstStyle/>
+                    <a:p>
+                      <a:r>
+                        <a:rPr sz="1100" b="0">
+                          <a:solidFill>
+                            <a:srgbClr val="282828"/>
+                          </a:solidFill>
+                          <a:latin typeface="Arial"/>
+                        </a:rPr>
+                        <a:t>S1 (30.6 nm)</a:t>
+                      </a:r>
+                    </a:p>
+                  </a:txBody>
+                  <a:tcPr marL="54864" marR="54864" marT="18288" marB="18288">
+                    <a:solidFill>
+                      <a:srgbClr val="FFFFFF"/>
+                    </a:solidFill>
+                  </a:tcPr>
+                </a:tc>
+                <a:tc>
+                  <a:txBody>
+                    <a:bodyPr wrap="square"/>
+                    <a:lstStyle/>
+                    <a:p>
+                      <a:r>
+                        <a:rPr sz="1100" b="0">
+                          <a:solidFill>
+                            <a:srgbClr val="282828"/>
+                          </a:solidFill>
+                          <a:latin typeface="Arial"/>
+                        </a:rPr>
+                        <a:t>oi_map_fig:43</a:t>
+                      </a:r>
+                    </a:p>
+                  </a:txBody>
+                  <a:tcPr marL="54864" marR="54864" marT="18288" marB="18288">
+                    <a:solidFill>
+                      <a:srgbClr val="FFFFFF"/>
+                    </a:solidFill>
+                  </a:tcPr>
+                </a:tc>
+              </a:tr>
+            </a:tbl>
+          </a:graphicData>
+        </a:graphic>
+      </p:graphicFrame>
+      <p:sp>
+        <p:nvSpPr>
+          <p:cNvPr id="6" name="TextBox 5"/>
           <p:cNvSpPr txBox="1"/>
           <p:nvPr/>
         </p:nvSpPr>
         <p:spPr>
           <a:xfrm>
-            <a:off x="6400800" y="1298448"/>
-            <a:ext cx="5394960" cy="274320"/>
+            <a:off x="411480" y="4099941"/>
+            <a:ext cx="5806440" cy="274320"/>
           </a:xfrm>
           <a:prstGeom prst="rect">
             <a:avLst/>
@@ -6263,20 +6603,20 @@
                 </a:solidFill>
                 <a:latin typeface="Arial"/>
               </a:rPr>
-              <a:t>•  Why it matters here: the retired second instance (slide B5's exhibit) failed precisely where documentation had not yet compiled the lesson.  This experiment measures how far the NOW-committed docs and gates carry an unassisted user.</a:t>
-            </a:r>
-          </a:p>
-        </p:txBody>
-      </p:sp>
-      <p:sp>
-        <p:nvSpPr>
-          <p:cNvPr id="6" name="TextBox 5"/>
+              <a:t>•  One optical root cause, in the packet's own words: the S1 solve runs far deeper than the source rung (20.9 / 30.6 nm vs the reported 159), and "the S2 rung measures the S1 design as much as the offset" — taken past the point where the offset box traces at all.  The docs NAME the mechanism and offer no guard, cap, or knob.</a:t>
+            </a:r>
+          </a:p>
+        </p:txBody>
+      </p:sp>
+      <p:sp>
+        <p:nvSpPr>
+          <p:cNvPr id="7" name="TextBox 6"/>
           <p:cNvSpPr txBox="1"/>
           <p:nvPr/>
         </p:nvSpPr>
         <p:spPr>
           <a:xfrm>
-            <a:off x="6400800" y="2267712"/>
+            <a:off x="6400800" y="1298448"/>
             <a:ext cx="5394960" cy="274320"/>
           </a:xfrm>
           <a:prstGeom prst="rect">
@@ -6296,13 +6636,148 @@
               </a:spcAft>
             </a:pPr>
             <a:r>
+              <a:rPr sz="1200" b="0">
+                <a:solidFill>
+                  <a:srgbClr val="282828"/>
+                </a:solidFill>
+                <a:latin typeface="Arial"/>
+              </a:rPr>
+              <a:t>•  The frictions to act on first (of 15, all in the committed report):</a:t>
+            </a:r>
+          </a:p>
+          <a:p>
+            <a:pPr>
+              <a:spcAft>
+                <a:spcPts val="600"/>
+              </a:spcAft>
+            </a:pPr>
+            <a:r>
+              <a:rPr sz="1200" b="0">
+                <a:solidFill>
+                  <a:srgbClr val="282828"/>
+                </a:solidFill>
+                <a:latin typeface="Arial"/>
+              </a:rPr>
+              <a:t>•  F7 — a dense-map headline can be computed from ONE surviving field point, with no warning: attempt 2's S2 printed [max 768194.5, avg 768194.5, std 0.0] — one finite point of 121; the failed fraction is never reported.</a:t>
+            </a:r>
+          </a:p>
+          <a:p>
+            <a:pPr>
+              <a:spcAft>
+                <a:spcPts val="600"/>
+              </a:spcAft>
+            </a:pPr>
+            <a:r>
+              <a:rPr sz="1200" b="0">
+                <a:solidFill>
+                  <a:srgbClr val="282828"/>
+                </a:solidFill>
+                <a:latin typeface="Arial"/>
+              </a:rPr>
+              <a:t>•  F8 — the flow proceeds from a design it has already scored as unusable: one check there converts three opaque crashes into one accurate sentence.</a:t>
+            </a:r>
+          </a:p>
+          <a:p>
+            <a:pPr>
+              <a:spcAft>
+                <a:spcPts val="600"/>
+              </a:spcAft>
+            </a:pPr>
+            <a:r>
+              <a:rPr sz="1200" b="0">
+                <a:solidFill>
+                  <a:srgbClr val="282828"/>
+                </a:solidFill>
+                <a:latin typeface="Arial"/>
+              </a:rPr>
+              <a:t>•  F1/F2 — the README's own run recipe errors on the path, and oi_story is undocumented outside its help.</a:t>
+            </a:r>
+          </a:p>
+          <a:p>
+            <a:pPr>
+              <a:spcAft>
+                <a:spcPts val="600"/>
+              </a:spcAft>
+            </a:pPr>
+            <a:r>
+              <a:rPr sz="1200" b="0">
+                <a:solidFill>
+                  <a:srgbClr val="282828"/>
+                </a:solidFill>
+                <a:latin typeface="Arial"/>
+              </a:rPr>
+              <a:t>•  F3/F4 — no documented way to choose the envelope, and seed_R1_m is load-bearing with nothing saying so.</a:t>
+            </a:r>
+          </a:p>
+          <a:p>
+            <a:pPr>
+              <a:spcAft>
+                <a:spcPts val="600"/>
+              </a:spcAft>
+            </a:pPr>
+            <a:r>
+              <a:rPr sz="1200" b="0">
+                <a:solidFill>
+                  <a:srgbClr val="282828"/>
+                </a:solidFill>
+                <a:latin typeface="Arial"/>
+              </a:rPr>
+              <a:t>•  F13 — the addendum's 25-solve-field lesson never reached the nsolve default or its help.</a:t>
+            </a:r>
+          </a:p>
+          <a:p>
+            <a:pPr>
+              <a:spcAft>
+                <a:spcPts val="600"/>
+              </a:spcAft>
+            </a:pPr>
+            <a:r>
+              <a:rPr sz="1200" b="0">
+                <a:solidFill>
+                  <a:srgbClr val="282828"/>
+                </a:solidFill>
+                <a:latin typeface="Arial"/>
+              </a:rPr>
+              <a:t>•  What WORKED: the constraint conventions were guessable and the gates confirmed the guesses; the packet's t4 retraction kept the user out of the retired trap without opening it.</a:t>
+            </a:r>
+          </a:p>
+        </p:txBody>
+      </p:sp>
+      <p:sp>
+        <p:nvSpPr>
+          <p:cNvPr id="8" name="TextBox 7"/>
+          <p:cNvSpPr txBox="1"/>
+          <p:nvPr/>
+        </p:nvSpPr>
+        <p:spPr>
+          <a:xfrm>
+            <a:off x="6400800" y="5684520"/>
+            <a:ext cx="5394960" cy="274320"/>
+          </a:xfrm>
+          <a:prstGeom prst="rect">
+            <a:avLst/>
+          </a:prstGeom>
+          <a:noFill/>
+        </p:spPr>
+        <p:txBody>
+          <a:bodyPr wrap="square">
+            <a:spAutoFit/>
+          </a:bodyPr>
+          <a:lstStyle/>
+          <a:p>
+            <a:pPr>
+              <a:spcAft>
+                <a:spcPts val="600"/>
+              </a:spcAft>
+            </a:pPr>
+            <a:r>
               <a:rPr sz="1050" b="0">
                 <a:solidFill>
                   <a:srgbClr val="6E6E6E"/>
                 </a:solidFill>
                 <a:latin typeface="Arial"/>
               </a:rPr>
-              <a:t>Protocol: BRIEF_oi_unguided (repo-external instrument; the report commits as challenges/rodgers3/t5_unguided_REPORT.md).</a:t>
+              <a:t>Instrument: BRIEF_oi_unguided; deliverable: challenges/rodgers3/t5_unguided_REPORT.md (verbatim, committed).  A negative result is a valid result — this one prices the gap between "documented" and "actionable".</a:t>
             </a:r>
           </a:p>
         </p:txBody>
@@ -6375,7 +6850,7 @@
                 </a:solidFill>
                 <a:latin typeface="Arial"/>
               </a:rPr>
-              <a:t>Questions for this audience</a:t>
+              <a:t>The F15 result feeds both camps — that is the question</a:t>
             </a:r>
           </a:p>
         </p:txBody>
@@ -6458,7 +6933,7 @@
                 </a:solidFill>
                 <a:latin typeface="Arial"/>
               </a:rPr>
-              <a:t>•  The evidence FOR, from this arc: every defect found was a CONCEPTUAL coupling — a frame convention, a metric reference, a constraint model — that documentation had not prevented; agent-in-the-loop found and fixed each in hours; the gotcha corpus already exists and could ship as a runtime advisor (macos.assist: "you are poking a segment whose grid frame differs from its Mon frame — the response will not localize").</a:t>
+              <a:t>•  FOR, from this arc: every defect found was a CONCEPTUAL coupling — a frame convention, a metric reference, a constraint model — that documentation had not prevented; agent-in-the-loop found and fixed each in hours.  And F15's one conceptual failure (S1 depth poisoning offset traceability) was DOCUMENTED and still not actionable — the case for advice AT CALL TIME ("your S1 is 8x deeper than the reference; expect the offset box to lose rays").</a:t>
             </a:r>
           </a:p>
           <a:p>
@@ -6474,7 +6949,7 @@
                 </a:solidFill>
                 <a:latin typeface="Arial"/>
               </a:rPr>
-              <a:t>•  The evidence AGAINST, from the same arc: every fix COMPILED into a check — the prescription validator, the pose bound, the signed piercing measure, the gate map of D13.  Compiled knowledge is inspectable, testable, and maintenance-stable; a runtime assistant is none of those by default.  Slide F15 measures how far docs + gates alone go.</a:t>
+              <a:t>•  AGAINST, from the same arc: every fix COMPILED into a check — the prescription validator, the pose bound, the signed piercing measure, the gate map — and 13 of F15's 15 frictions compile the same way (guards, caps, doc lines; F8 is literally "one check converts three crashes into one sentence").  Compiled knowledge is inspectable, testable, maintenance-stable; a runtime assistant is none of those by default.</a:t>
             </a:r>
           </a:p>
         </p:txBody>
@@ -6600,7 +7075,7 @@
                 </a:solidFill>
                 <a:latin typeface="Arial"/>
               </a:rPr>
-              <a:t>Discussion slide: questions are the deliverable.  Positions welcome; the F15 result will move this debate one way or the other.</a:t>
+              <a:t>Discussion slide: questions are the deliverable.  The measured input: docs + gates, as committed today, did NOT carry an unassisted user through a re-instance — and most of why is compilable.</a:t>
             </a:r>
           </a:p>
         </p:txBody>

</xml_diff>

<commit_message>
walk deck F16: the endgame close, parsed from the record
parse_endgame() joins the records parsers; F16's headline and takeaway
now carry the close (hull 28.7 mm clears as-is; re-solve 47.1 nm at
30.9 mm in the same envelope; the 6-iteration under-solve named).
Render-checked; footnote trimmed to fit.  DRAFT pending sign-off.

Co-Authored-By: Claude Fable 5 <noreply@anthropic.com>
</commit_message>
<xml_diff>
--- a/mmacos/challenges/rodgers3/deck_rodgers3_walk.pptx
+++ b/mmacos/challenges/rodgers3/deck_rodgers3_walk.pptx
@@ -6851,7 +6851,7 @@
                 </a:solidFill>
                 <a:latin typeface="Arial"/>
               </a:rPr>
-              <a:t>The fixed template diagnoses everything and still stalls; the continuation walk lands 69.8 nm — 8531x better</a:t>
+              <a:t>The walk lands 69.8 nm (8531x better); the endgame re-solve then closes the last gate at NEGATIVE cost — 47.1 nm at 30.9 mm</a:t>
             </a:r>
           </a:p>
         </p:txBody>
@@ -7690,7 +7690,7 @@
                 </a:solidFill>
                 <a:latin typeface="Arial"/>
               </a:rPr>
-              <a:t>•  Exit PASS at every step; the remaining gap is stated separately: the signed clearance floor tightens monotonically as the box opens and crosses the 25 mm knee only at the last step — packaging, not wavefront, is now the binding constraint.</a:t>
+              <a:t>•  Exit PASS at every step — and the last-step clearance residual (17.8 vs 25 mm) CLOSED post-walk: the truer hull model reads the committed design at 28.7 mm (clears as-is), and a restart re-solve in the SAME envelope lands 47.1 nm at a 30.9 mm floor — better than the walk on both axes.  The final step had stopped at 6 iterations on the WFE-only plateau break; clearance was never blocking, just under-solved.</a:t>
             </a:r>
           </a:p>
         </p:txBody>
@@ -7711,8 +7711,8 @@
         </p:blipFill>
         <p:spPr>
           <a:xfrm>
-            <a:off x="8010003" y="3991355"/>
-            <a:ext cx="2176552" cy="1874011"/>
+            <a:off x="8089655" y="4387596"/>
+            <a:ext cx="2017249" cy="1736851"/>
           </a:xfrm>
           <a:prstGeom prst="rect">
             <a:avLst/>
@@ -7727,7 +7727,7 @@
         </p:nvSpPr>
         <p:spPr>
           <a:xfrm>
-            <a:off x="6400800" y="5883655"/>
+            <a:off x="6400800" y="6142735"/>
             <a:ext cx="5394960" cy="229107"/>
           </a:xfrm>
           <a:prstGeom prst="rect">
@@ -7766,7 +7766,7 @@
         </p:nvSpPr>
         <p:spPr>
           <a:xfrm>
-            <a:off x="6400800" y="6149339"/>
+            <a:off x="6400800" y="6408419"/>
             <a:ext cx="5394960" cy="274320"/>
           </a:xfrm>
           <a:prstGeom prst="rect">
@@ -7792,7 +7792,7 @@
                 </a:solidFill>
                 <a:latin typeface="Arial"/>
               </a:rPr>
-              <a:t>Records: t5_redemption/t5r_REPORT.md + t5_walk/t5_walk_REPORT.md (verdict PARTIAL — on packaging alone); runner: oi_walk.m (template dir).  Every number: the cover's metric contract.</a:t>
+              <a:t>Records: the t5_redemption / t5_walk / t5_endgame REPORTs (offset_imager template dir); runners oi_walk.m + run_t5_endgame.m.  Every number: the cover contract.</a:t>
             </a:r>
           </a:p>
         </p:txBody>

</xml_diff>

<commit_message>
walk deck: figures round -- trend plot, stall exhibit, endgame map, params table
Section F grows to three slides (18 content total, deviation declared):
F16 = the walk (challenge-vs-instance params table, the t5r stall
layout as the failure exhibit, the new walk_trend figure -- map max +
clearance floor vs box width with the endgame stars, generated by
fig_walk_trend.m from the committed .mat records); F17 = the endgame
close (the 47.1 nm WFE map as the ladder-style closer + the hinge
price table, parsed rows); F18 = the discussion, refs updated.  C11
gains the S5-of-record layout beside its map.  parse_endgame extended
(price rows + env WFE trend).  Render-checked all four changed pages.
DRAFT pending sign-off.

Co-Authored-By: Claude Fable 5 <noreply@anthropic.com>
</commit_message>
<xml_diff>
--- a/mmacos/challenges/rodgers3/deck_rodgers3_walk.pptx
+++ b/mmacos/challenges/rodgers3/deck_rodgers3_walk.pptx
@@ -23,6 +23,7 @@
     <p:sldId id="271" r:id="rId22"/>
     <p:sldId id="272" r:id="rId23"/>
     <p:sldId id="273" r:id="rId24"/>
+    <p:sldId id="274" r:id="rId25"/>
   </p:sldIdLst>
   <p:sldSz cx="12191695" cy="6858000" type="screen4x3"/>
   <p:notesSz cx="6858000" cy="9144000"/>
@@ -3210,7 +3211,7 @@
                 </a:solidFill>
                 <a:latin typeface="Arial"/>
               </a:rPr>
-              <a:t>THE METRIC CONTRACT, once for the whole deck: strict RMS WFE, centroid reference on the stage's frozen focal plane, exit-pupil anchor, piston-only removal; quoted statistic = dense 11x11 map MAXIMUM over the field box.  Every WFE number on every slide inherits it.  Workbook genre: 17 content slides in six sections (budget deviation declared, DECK2_PLAN.md).  DRAFT — pending sign-off.</a:t>
+              <a:t>THE METRIC CONTRACT, once for the whole deck: strict RMS WFE, centroid reference on the stage's frozen focal plane, exit-pupil anchor, piston-only removal; quoted statistic = dense 11x11 map MAXIMUM over the field box.  Every WFE number on every slide inherits it.  Workbook genre: 18 content slides in six sections (budget deviation declared, DECK2_PLAN.md).  DRAFT — pending sign-off.</a:t>
             </a:r>
           </a:p>
         </p:txBody>
@@ -4597,7 +4598,7 @@
       </p:sp>
       <p:pic>
         <p:nvPicPr>
-          <p:cNvPr id="7" name="Picture 6" descr="s5b_legC_map.png"/>
+          <p:cNvPr id="7" name="Picture 6" descr="r3t_s5_layout.png"/>
           <p:cNvPicPr>
             <a:picLocks noChangeAspect="1"/>
           </p:cNvPicPr>
@@ -4611,8 +4612,8 @@
         </p:blipFill>
         <p:spPr>
           <a:xfrm>
-            <a:off x="7299570" y="1298448"/>
-            <a:ext cx="3597418" cy="3154172"/>
+            <a:off x="7983884" y="1298448"/>
+            <a:ext cx="2228791" cy="1919732"/>
           </a:xfrm>
           <a:prstGeom prst="rect">
             <a:avLst/>
@@ -4627,7 +4628,7 @@
         </p:nvSpPr>
         <p:spPr>
           <a:xfrm>
-            <a:off x="6400800" y="4470908"/>
+            <a:off x="6400800" y="3236468"/>
             <a:ext cx="5394960" cy="229107"/>
           </a:xfrm>
           <a:prstGeom prst="rect">
@@ -4653,20 +4654,83 @@
                 </a:solidFill>
                 <a:latin typeface="Arial"/>
               </a:rPr>
-              <a:t>The honest re-solve (probe C): 45.4 nm max, true floor 33.4 mm.</a:t>
-            </a:r>
-          </a:p>
-        </p:txBody>
-      </p:sp>
-      <p:sp>
-        <p:nvSpPr>
-          <p:cNvPr id="9" name="TextBox 8"/>
+              <a:t>The S5-of-record design, drawn: the layout every map on this slide belongs to.</a:t>
+            </a:r>
+          </a:p>
+        </p:txBody>
+      </p:sp>
+      <p:pic>
+        <p:nvPicPr>
+          <p:cNvPr id="9" name="Picture 8" descr="s5b_legC_map.png"/>
+          <p:cNvPicPr>
+            <a:picLocks noChangeAspect="1"/>
+          </p:cNvPicPr>
+          <p:nvPr/>
+        </p:nvPicPr>
+        <p:blipFill>
+          <a:blip r:embed="rId3"/>
+          <a:stretch>
+            <a:fillRect/>
+          </a:stretch>
+        </p:blipFill>
+        <p:spPr>
+          <a:xfrm>
+            <a:off x="8003526" y="3502152"/>
+            <a:ext cx="2189506" cy="1919732"/>
+          </a:xfrm>
+          <a:prstGeom prst="rect">
+            <a:avLst/>
+          </a:prstGeom>
+        </p:spPr>
+      </p:pic>
+      <p:sp>
+        <p:nvSpPr>
+          <p:cNvPr id="10" name="TextBox 9"/>
           <p:cNvSpPr txBox="1"/>
           <p:nvPr/>
         </p:nvSpPr>
         <p:spPr>
           <a:xfrm>
-            <a:off x="6400800" y="4736592"/>
+            <a:off x="6400800" y="5440171"/>
+            <a:ext cx="5394960" cy="229107"/>
+          </a:xfrm>
+          <a:prstGeom prst="rect">
+            <a:avLst/>
+          </a:prstGeom>
+          <a:noFill/>
+        </p:spPr>
+        <p:txBody>
+          <a:bodyPr wrap="square">
+            <a:spAutoFit/>
+          </a:bodyPr>
+          <a:lstStyle/>
+          <a:p>
+            <a:pPr algn="ctr">
+              <a:spcAft>
+                <a:spcPts val="0"/>
+              </a:spcAft>
+            </a:pPr>
+            <a:r>
+              <a:rPr sz="1000" b="0">
+                <a:solidFill>
+                  <a:srgbClr val="6E6E6E"/>
+                </a:solidFill>
+                <a:latin typeface="Arial"/>
+              </a:rPr>
+              <a:t>The honest re-solve (probe C): 45.4 nm max, true floor 33.4 mm.</a:t>
+            </a:r>
+          </a:p>
+        </p:txBody>
+      </p:sp>
+      <p:sp>
+        <p:nvSpPr>
+          <p:cNvPr id="11" name="TextBox 10"/>
+          <p:cNvSpPr txBox="1"/>
+          <p:nvPr/>
+        </p:nvSpPr>
+        <p:spPr>
+          <a:xfrm>
+            <a:off x="6400800" y="5705855"/>
             <a:ext cx="5394960" cy="274320"/>
           </a:xfrm>
           <a:prstGeom prst="rect">
@@ -6778,7 +6842,7 @@
                 </a:solidFill>
                 <a:latin typeface="Arial"/>
               </a:rPr>
-              <a:t>Instrument: BRIEF_oi_unguided; deliverable: challenges/rodgers3/t5_unguided_REPORT.md (verbatim, committed).  A negative result is a valid result — this one prices the gap between "documented" and "actionable".  Acts 2 and 3 — the fixes, then the walk — next slide.</a:t>
+              <a:t>Instrument: BRIEF_oi_unguided; deliverable: challenges/rodgers3/t5_unguided_REPORT.md (verbatim, committed).  A negative result is a valid result — this one prices the gap between "documented" and "actionable".  Acts 2 and 3 — the fixes, the walk, the close — next two slides.</a:t>
             </a:r>
           </a:p>
         </p:txBody>
@@ -6851,7 +6915,7 @@
                 </a:solidFill>
                 <a:latin typeface="Arial"/>
               </a:rPr>
-              <a:t>The walk lands 69.8 nm (8531x better); the endgame re-solve then closes the last gate at NEGATIVE cost — 47.1 nm at 30.9 mm</a:t>
+              <a:t>The cold start dies 205 mm inside the glass; the walk lands 69.8 nm — 8531x better</a:t>
             </a:r>
           </a:p>
         </p:txBody>
@@ -6934,23 +6998,7 @@
                 </a:solidFill>
                 <a:latin typeface="Arial"/>
               </a:rPr>
-              <a:t>•  Act 2 — the REDEMPTION rerun (run_t5r): the same instance on the fixed template (S1 depth cap, INVALID-map honesty, sentinel refusal, graceful ray loss).  ZERO crashes, and every failure now diagnoses itself in one line: the capped S1 lands 74.9 nm, S2 prints "INVALID — 104/121 fields lost every ray", the exit gate says "unmeasurable" instead of dying.  But S3–S5 stall at ~596 µm with the beam 205 mm INSIDE the glass: a cold start at the full 15° box is outside the convergent basin.  Robustness redeemed; convergence not — and both counter-designs stall at the same level, so it is the basin, not the freedom path.</a:t>
-            </a:r>
-          </a:p>
-          <a:p>
-            <a:pPr>
-              <a:spcAft>
-                <a:spcPts val="600"/>
-              </a:spcAft>
-            </a:pPr>
-            <a:r>
-              <a:rPr sz="1200" b="0">
-                <a:solidFill>
-                  <a:srgbClr val="282828"/>
-                </a:solidFill>
-                <a:latin typeface="Arial"/>
-              </a:rPr>
-              <a:t>•  Act 3 — the WALK (oi_walk): solve an easy 5° box first (diffraction-limited, clears comfortably), then walk the box open toward the target, carrying each solved design as the next step's warm start.  Full freedom + all constraint rows at every step; every carried design is screened at the widened box before solving — it traced first try at every step: the basin moves smoothly with the box.</a:t>
+              <a:t>•  The instance against the source challenge (a fresh, HARDER system — bigger beam, faster, tighter clearances):</a:t>
             </a:r>
           </a:p>
         </p:txBody>
@@ -6964,7 +7012,573 @@
           <p:nvPr/>
         </p:nvGraphicFramePr>
         <p:xfrm>
-          <a:off x="6400800" y="1298448"/>
+          <a:off x="411480" y="1871472"/>
+          <a:ext cx="5806439" cy="1680210"/>
+        </p:xfrm>
+        <a:graphic>
+          <a:graphicData uri="http://schemas.openxmlformats.org/drawingml/2006/table">
+            <a:tbl>
+              <a:tblPr firstRow="1" bandRow="1">
+                <a:tableStyleId>{5C22544A-7EE6-4342-B048-85BDC9FD1C3A}</a:tableStyleId>
+              </a:tblPr>
+              <a:tblGrid>
+                <a:gridCol w="1138517"/>
+                <a:gridCol w="2277035"/>
+                <a:gridCol w="2390887"/>
+              </a:tblGrid>
+              <a:tr h="280035">
+                <a:tc>
+                  <a:txBody>
+                    <a:bodyPr wrap="square"/>
+                    <a:lstStyle/>
+                    <a:p/>
+                  </a:txBody>
+                  <a:tcPr marL="54864" marR="54864" marT="18288" marB="18288">
+                    <a:solidFill>
+                      <a:srgbClr val="1F4E79"/>
+                    </a:solidFill>
+                  </a:tcPr>
+                </a:tc>
+                <a:tc>
+                  <a:txBody>
+                    <a:bodyPr wrap="square"/>
+                    <a:lstStyle/>
+                    <a:p>
+                      <a:r>
+                        <a:rPr sz="1100" b="1">
+                          <a:solidFill>
+                            <a:srgbClr val="FFFFFF"/>
+                          </a:solidFill>
+                          <a:latin typeface="Arial"/>
+                        </a:rPr>
+                        <a:t>rodgers3 challenge</a:t>
+                      </a:r>
+                    </a:p>
+                  </a:txBody>
+                  <a:tcPr marL="54864" marR="54864" marT="18288" marB="18288">
+                    <a:solidFill>
+                      <a:srgbClr val="1F4E79"/>
+                    </a:solidFill>
+                  </a:tcPr>
+                </a:tc>
+                <a:tc>
+                  <a:txBody>
+                    <a:bodyPr wrap="square"/>
+                    <a:lstStyle/>
+                    <a:p>
+                      <a:r>
+                        <a:rPr sz="1100" b="1">
+                          <a:solidFill>
+                            <a:srgbClr val="FFFFFF"/>
+                          </a:solidFill>
+                          <a:latin typeface="Arial"/>
+                        </a:rPr>
+                        <a:t>t5 walk instance</a:t>
+                      </a:r>
+                    </a:p>
+                  </a:txBody>
+                  <a:tcPr marL="54864" marR="54864" marT="18288" marB="18288">
+                    <a:solidFill>
+                      <a:srgbClr val="1F4E79"/>
+                    </a:solidFill>
+                  </a:tcPr>
+                </a:tc>
+              </a:tr>
+              <a:tr h="280035">
+                <a:tc>
+                  <a:txBody>
+                    <a:bodyPr wrap="square"/>
+                    <a:lstStyle/>
+                    <a:p>
+                      <a:r>
+                        <a:rPr sz="1100" b="0">
+                          <a:solidFill>
+                            <a:srgbClr val="282828"/>
+                          </a:solidFill>
+                          <a:latin typeface="Arial"/>
+                        </a:rPr>
+                        <a:t>EPD / F#</a:t>
+                      </a:r>
+                    </a:p>
+                  </a:txBody>
+                  <a:tcPr marL="54864" marR="54864" marT="18288" marB="18288">
+                    <a:solidFill>
+                      <a:srgbClr val="FFFFFF"/>
+                    </a:solidFill>
+                  </a:tcPr>
+                </a:tc>
+                <a:tc>
+                  <a:txBody>
+                    <a:bodyPr wrap="square"/>
+                    <a:lstStyle/>
+                    <a:p>
+                      <a:r>
+                        <a:rPr sz="1100" b="0">
+                          <a:solidFill>
+                            <a:srgbClr val="282828"/>
+                          </a:solidFill>
+                          <a:latin typeface="Arial"/>
+                        </a:rPr>
+                        <a:t>75 mm / F4.0</a:t>
+                      </a:r>
+                    </a:p>
+                  </a:txBody>
+                  <a:tcPr marL="54864" marR="54864" marT="18288" marB="18288">
+                    <a:solidFill>
+                      <a:srgbClr val="FFFFFF"/>
+                    </a:solidFill>
+                  </a:tcPr>
+                </a:tc>
+                <a:tc>
+                  <a:txBody>
+                    <a:bodyPr wrap="square"/>
+                    <a:lstStyle/>
+                    <a:p>
+                      <a:r>
+                        <a:rPr sz="1100" b="0">
+                          <a:solidFill>
+                            <a:srgbClr val="282828"/>
+                          </a:solidFill>
+                          <a:latin typeface="Arial"/>
+                        </a:rPr>
+                        <a:t>150 mm / F3.3</a:t>
+                      </a:r>
+                    </a:p>
+                  </a:txBody>
+                  <a:tcPr marL="54864" marR="54864" marT="18288" marB="18288">
+                    <a:solidFill>
+                      <a:srgbClr val="FFFFFF"/>
+                    </a:solidFill>
+                  </a:tcPr>
+                </a:tc>
+              </a:tr>
+              <a:tr h="280035">
+                <a:tc>
+                  <a:txBody>
+                    <a:bodyPr wrap="square"/>
+                    <a:lstStyle/>
+                    <a:p>
+                      <a:r>
+                        <a:rPr sz="1100" b="0">
+                          <a:solidFill>
+                            <a:srgbClr val="282828"/>
+                          </a:solidFill>
+                          <a:latin typeface="Arial"/>
+                        </a:rPr>
+                        <a:t>field box</a:t>
+                      </a:r>
+                    </a:p>
+                  </a:txBody>
+                  <a:tcPr marL="54864" marR="54864" marT="18288" marB="18288">
+                    <a:solidFill>
+                      <a:srgbClr val="ECF1F6"/>
+                    </a:solidFill>
+                  </a:tcPr>
+                </a:tc>
+                <a:tc>
+                  <a:txBody>
+                    <a:bodyPr wrap="square"/>
+                    <a:lstStyle/>
+                    <a:p>
+                      <a:r>
+                        <a:rPr sz="1100" b="0">
+                          <a:solidFill>
+                            <a:srgbClr val="282828"/>
+                          </a:solidFill>
+                          <a:latin typeface="Arial"/>
+                        </a:rPr>
+                        <a:t>20x20° at YAN +22°</a:t>
+                      </a:r>
+                    </a:p>
+                  </a:txBody>
+                  <a:tcPr marL="54864" marR="54864" marT="18288" marB="18288">
+                    <a:solidFill>
+                      <a:srgbClr val="ECF1F6"/>
+                    </a:solidFill>
+                  </a:tcPr>
+                </a:tc>
+                <a:tc>
+                  <a:txBody>
+                    <a:bodyPr wrap="square"/>
+                    <a:lstStyle/>
+                    <a:p>
+                      <a:r>
+                        <a:rPr sz="1100" b="0">
+                          <a:solidFill>
+                            <a:srgbClr val="282828"/>
+                          </a:solidFill>
+                          <a:latin typeface="Arial"/>
+                        </a:rPr>
+                        <a:t>15x15° at YAN +22.5°</a:t>
+                      </a:r>
+                    </a:p>
+                  </a:txBody>
+                  <a:tcPr marL="54864" marR="54864" marT="18288" marB="18288">
+                    <a:solidFill>
+                      <a:srgbClr val="ECF1F6"/>
+                    </a:solidFill>
+                  </a:tcPr>
+                </a:tc>
+              </a:tr>
+              <a:tr h="280035">
+                <a:tc>
+                  <a:txBody>
+                    <a:bodyPr wrap="square"/>
+                    <a:lstStyle/>
+                    <a:p>
+                      <a:r>
+                        <a:rPr sz="1100" b="0">
+                          <a:solidFill>
+                            <a:srgbClr val="282828"/>
+                          </a:solidFill>
+                          <a:latin typeface="Arial"/>
+                        </a:rPr>
+                        <a:t>clearances</a:t>
+                      </a:r>
+                    </a:p>
+                  </a:txBody>
+                  <a:tcPr marL="54864" marR="54864" marT="18288" marB="18288">
+                    <a:solidFill>
+                      <a:srgbClr val="FFFFFF"/>
+                    </a:solidFill>
+                  </a:tcPr>
+                </a:tc>
+                <a:tc>
+                  <a:txBody>
+                    <a:bodyPr wrap="square"/>
+                    <a:lstStyle/>
+                    <a:p>
+                      <a:r>
+                        <a:rPr sz="1100" b="0">
+                          <a:solidFill>
+                            <a:srgbClr val="282828"/>
+                          </a:solidFill>
+                          <a:latin typeface="Arial"/>
+                        </a:rPr>
+                        <a:t>≥ 50 / 35 mm</a:t>
+                      </a:r>
+                    </a:p>
+                  </a:txBody>
+                  <a:tcPr marL="54864" marR="54864" marT="18288" marB="18288">
+                    <a:solidFill>
+                      <a:srgbClr val="FFFFFF"/>
+                    </a:solidFill>
+                  </a:tcPr>
+                </a:tc>
+                <a:tc>
+                  <a:txBody>
+                    <a:bodyPr wrap="square"/>
+                    <a:lstStyle/>
+                    <a:p>
+                      <a:r>
+                        <a:rPr sz="1100" b="0">
+                          <a:solidFill>
+                            <a:srgbClr val="282828"/>
+                          </a:solidFill>
+                          <a:latin typeface="Arial"/>
+                        </a:rPr>
+                        <a:t>≥ 40 / 25 mm</a:t>
+                      </a:r>
+                    </a:p>
+                  </a:txBody>
+                  <a:tcPr marL="54864" marR="54864" marT="18288" marB="18288">
+                    <a:solidFill>
+                      <a:srgbClr val="FFFFFF"/>
+                    </a:solidFill>
+                  </a:tcPr>
+                </a:tc>
+              </a:tr>
+              <a:tr h="280035">
+                <a:tc>
+                  <a:txBody>
+                    <a:bodyPr wrap="square"/>
+                    <a:lstStyle/>
+                    <a:p>
+                      <a:r>
+                        <a:rPr sz="1100" b="0">
+                          <a:solidFill>
+                            <a:srgbClr val="282828"/>
+                          </a:solidFill>
+                          <a:latin typeface="Arial"/>
+                        </a:rPr>
+                        <a:t>envelope</a:t>
+                      </a:r>
+                    </a:p>
+                  </a:txBody>
+                  <a:tcPr marL="54864" marR="54864" marT="18288" marB="18288">
+                    <a:solidFill>
+                      <a:srgbClr val="ECF1F6"/>
+                    </a:solidFill>
+                  </a:tcPr>
+                </a:tc>
+                <a:tc>
+                  <a:txBody>
+                    <a:bodyPr wrap="square"/>
+                    <a:lstStyle/>
+                    <a:p>
+                      <a:r>
+                        <a:rPr sz="1100" b="0">
+                          <a:solidFill>
+                            <a:srgbClr val="282828"/>
+                          </a:solidFill>
+                          <a:latin typeface="Arial"/>
+                        </a:rPr>
+                        <a:t>native .seq spacings</a:t>
+                      </a:r>
+                    </a:p>
+                  </a:txBody>
+                  <a:tcPr marL="54864" marR="54864" marT="18288" marB="18288">
+                    <a:solidFill>
+                      <a:srgbClr val="ECF1F6"/>
+                    </a:solidFill>
+                  </a:tcPr>
+                </a:tc>
+                <a:tc>
+                  <a:txBody>
+                    <a:bodyPr wrap="square"/>
+                    <a:lstStyle/>
+                    <a:p>
+                      <a:r>
+                        <a:rPr sz="1100" b="0">
+                          <a:solidFill>
+                            <a:srgbClr val="282828"/>
+                          </a:solidFill>
+                          <a:latin typeface="Arial"/>
+                        </a:rPr>
+                        <a:t>rodgers3 W-fold x1.65</a:t>
+                      </a:r>
+                    </a:p>
+                  </a:txBody>
+                  <a:tcPr marL="54864" marR="54864" marT="18288" marB="18288">
+                    <a:solidFill>
+                      <a:srgbClr val="ECF1F6"/>
+                    </a:solidFill>
+                  </a:tcPr>
+                </a:tc>
+              </a:tr>
+              <a:tr h="280035">
+                <a:tc>
+                  <a:txBody>
+                    <a:bodyPr wrap="square"/>
+                    <a:lstStyle/>
+                    <a:p>
+                      <a:r>
+                        <a:rPr sz="1100" b="0">
+                          <a:solidFill>
+                            <a:srgbClr val="282828"/>
+                          </a:solidFill>
+                          <a:latin typeface="Arial"/>
+                        </a:rPr>
+                        <a:t>exit pin</a:t>
+                      </a:r>
+                    </a:p>
+                  </a:txBody>
+                  <a:tcPr marL="54864" marR="54864" marT="18288" marB="18288">
+                    <a:solidFill>
+                      <a:srgbClr val="FFFFFF"/>
+                    </a:solidFill>
+                  </a:tcPr>
+                </a:tc>
+                <a:tc>
+                  <a:txBody>
+                    <a:bodyPr wrap="square"/>
+                    <a:lstStyle/>
+                    <a:p>
+                      <a:r>
+                        <a:rPr sz="1100" b="0">
+                          <a:solidFill>
+                            <a:srgbClr val="282828"/>
+                          </a:solidFill>
+                          <a:latin typeface="Arial"/>
+                        </a:rPr>
+                        <a:t>horizontal</a:t>
+                      </a:r>
+                    </a:p>
+                  </a:txBody>
+                  <a:tcPr marL="54864" marR="54864" marT="18288" marB="18288">
+                    <a:solidFill>
+                      <a:srgbClr val="FFFFFF"/>
+                    </a:solidFill>
+                  </a:tcPr>
+                </a:tc>
+                <a:tc>
+                  <a:txBody>
+                    <a:bodyPr wrap="square"/>
+                    <a:lstStyle/>
+                    <a:p>
+                      <a:r>
+                        <a:rPr sz="1100" b="0">
+                          <a:solidFill>
+                            <a:srgbClr val="282828"/>
+                          </a:solidFill>
+                          <a:latin typeface="Arial"/>
+                        </a:rPr>
+                        <a:t>horizontal</a:t>
+                      </a:r>
+                    </a:p>
+                  </a:txBody>
+                  <a:tcPr marL="54864" marR="54864" marT="18288" marB="18288">
+                    <a:solidFill>
+                      <a:srgbClr val="FFFFFF"/>
+                    </a:solidFill>
+                  </a:tcPr>
+                </a:tc>
+              </a:tr>
+            </a:tbl>
+          </a:graphicData>
+        </a:graphic>
+      </p:graphicFrame>
+      <p:sp>
+        <p:nvSpPr>
+          <p:cNvPr id="6" name="TextBox 5"/>
+          <p:cNvSpPr txBox="1"/>
+          <p:nvPr/>
+        </p:nvSpPr>
+        <p:spPr>
+          <a:xfrm>
+            <a:off x="411480" y="3697986"/>
+            <a:ext cx="5806440" cy="274320"/>
+          </a:xfrm>
+          <a:prstGeom prst="rect">
+            <a:avLst/>
+          </a:prstGeom>
+          <a:noFill/>
+        </p:spPr>
+        <p:txBody>
+          <a:bodyPr wrap="square">
+            <a:spAutoFit/>
+          </a:bodyPr>
+          <a:lstStyle/>
+          <a:p>
+            <a:pPr>
+              <a:spcAft>
+                <a:spcPts val="600"/>
+              </a:spcAft>
+            </a:pPr>
+            <a:r>
+              <a:rPr sz="1200" b="0">
+                <a:solidFill>
+                  <a:srgbClr val="282828"/>
+                </a:solidFill>
+                <a:latin typeface="Arial"/>
+              </a:rPr>
+              <a:t>•  Act 2 — the REDEMPTION rerun (run_t5r): ZERO crashes, every failure self-diagnosed (capped S1 74.9 nm; "INVALID — 104/121 fields lost"; exit "unmeasurable") — but S3–S5 stall at ~596 µm with the beam 205 mm INSIDE the glass (figure): the cold start is outside the convergent basin, and both counter-designs stall with it.</a:t>
+            </a:r>
+          </a:p>
+        </p:txBody>
+      </p:sp>
+      <p:pic>
+        <p:nvPicPr>
+          <p:cNvPr id="7" name="Picture 6" descr="t5r_s4_layout.png"/>
+          <p:cNvPicPr>
+            <a:picLocks noChangeAspect="1"/>
+          </p:cNvPicPr>
+          <p:nvPr/>
+        </p:nvPicPr>
+        <p:blipFill>
+          <a:blip r:embed="rId2"/>
+          <a:stretch>
+            <a:fillRect/>
+          </a:stretch>
+        </p:blipFill>
+        <p:spPr>
+          <a:xfrm>
+            <a:off x="2588086" y="4865370"/>
+            <a:ext cx="1453226" cy="1251712"/>
+          </a:xfrm>
+          <a:prstGeom prst="rect">
+            <a:avLst/>
+          </a:prstGeom>
+        </p:spPr>
+      </p:pic>
+      <p:sp>
+        <p:nvSpPr>
+          <p:cNvPr id="8" name="TextBox 7"/>
+          <p:cNvSpPr txBox="1"/>
+          <p:nvPr/>
+        </p:nvSpPr>
+        <p:spPr>
+          <a:xfrm>
+            <a:off x="411480" y="6135370"/>
+            <a:ext cx="5806440" cy="394208"/>
+          </a:xfrm>
+          <a:prstGeom prst="rect">
+            <a:avLst/>
+          </a:prstGeom>
+          <a:noFill/>
+        </p:spPr>
+        <p:txBody>
+          <a:bodyPr wrap="square">
+            <a:spAutoFit/>
+          </a:bodyPr>
+          <a:lstStyle/>
+          <a:p>
+            <a:pPr algn="ctr">
+              <a:spcAft>
+                <a:spcPts val="0"/>
+              </a:spcAft>
+            </a:pPr>
+            <a:r>
+              <a:rPr sz="1000" b="0">
+                <a:solidFill>
+                  <a:srgbClr val="6E6E6E"/>
+                </a:solidFill>
+                <a:latin typeface="Arial"/>
+              </a:rPr>
+              <a:t>The stall, drawn: the corner-field fans thread the mirrors — the layout no number can excuse.</a:t>
+            </a:r>
+          </a:p>
+        </p:txBody>
+      </p:sp>
+      <p:sp>
+        <p:nvSpPr>
+          <p:cNvPr id="9" name="TextBox 8"/>
+          <p:cNvSpPr txBox="1"/>
+          <p:nvPr/>
+        </p:nvSpPr>
+        <p:spPr>
+          <a:xfrm>
+            <a:off x="6400800" y="1298448"/>
+            <a:ext cx="5394960" cy="274320"/>
+          </a:xfrm>
+          <a:prstGeom prst="rect">
+            <a:avLst/>
+          </a:prstGeom>
+          <a:noFill/>
+        </p:spPr>
+        <p:txBody>
+          <a:bodyPr wrap="square">
+            <a:spAutoFit/>
+          </a:bodyPr>
+          <a:lstStyle/>
+          <a:p>
+            <a:pPr>
+              <a:spcAft>
+                <a:spcPts val="600"/>
+              </a:spcAft>
+            </a:pPr>
+            <a:r>
+              <a:rPr sz="1200" b="0">
+                <a:solidFill>
+                  <a:srgbClr val="282828"/>
+                </a:solidFill>
+                <a:latin typeface="Arial"/>
+              </a:rPr>
+              <a:t>•  Act 3 — the WALK (oi_walk): solve an easy 5° box, then open the box toward the target carrying each solved design as the next warm start — full freedom + all constraint rows at every step; every carried design traced the widened box first try.</a:t>
+            </a:r>
+          </a:p>
+        </p:txBody>
+      </p:sp>
+      <p:graphicFrame>
+        <p:nvGraphicFramePr>
+          <p:cNvPr id="10" name="Table 9"/>
+          <p:cNvGraphicFramePr>
+            <a:graphicFrameLocks noGrp="1"/>
+          </p:cNvGraphicFramePr>
+          <p:nvPr/>
+        </p:nvGraphicFramePr>
+        <p:xfrm>
+          <a:off x="6400800" y="2267712"/>
           <a:ext cx="5394958" cy="1577340"/>
         </p:xfrm>
         <a:graphic>
@@ -7656,15 +8270,78 @@
           </a:graphicData>
         </a:graphic>
       </p:graphicFrame>
-      <p:sp>
-        <p:nvSpPr>
-          <p:cNvPr id="6" name="TextBox 5"/>
+      <p:pic>
+        <p:nvPicPr>
+          <p:cNvPr id="11" name="Picture 10" descr="walk_trend.png"/>
+          <p:cNvPicPr>
+            <a:picLocks noChangeAspect="1"/>
+          </p:cNvPicPr>
+          <p:nvPr/>
+        </p:nvPicPr>
+        <p:blipFill>
+          <a:blip r:embed="rId3"/>
+          <a:stretch>
+            <a:fillRect/>
+          </a:stretch>
+        </p:blipFill>
+        <p:spPr>
+          <a:xfrm>
+            <a:off x="7521858" y="3991356"/>
+            <a:ext cx="3152842" cy="1846072"/>
+          </a:xfrm>
+          <a:prstGeom prst="rect">
+            <a:avLst/>
+          </a:prstGeom>
+        </p:spPr>
+      </p:pic>
+      <p:sp>
+        <p:nvSpPr>
+          <p:cNvPr id="12" name="TextBox 11"/>
           <p:cNvSpPr txBox="1"/>
           <p:nvPr/>
         </p:nvSpPr>
         <p:spPr>
           <a:xfrm>
-            <a:off x="6400800" y="3022091"/>
+            <a:off x="6400800" y="5855716"/>
+            <a:ext cx="5394960" cy="394208"/>
+          </a:xfrm>
+          <a:prstGeom prst="rect">
+            <a:avLst/>
+          </a:prstGeom>
+          <a:noFill/>
+        </p:spPr>
+        <p:txBody>
+          <a:bodyPr wrap="square">
+            <a:spAutoFit/>
+          </a:bodyPr>
+          <a:lstStyle/>
+          <a:p>
+            <a:pPr algn="ctr">
+              <a:spcAft>
+                <a:spcPts val="0"/>
+              </a:spcAft>
+            </a:pPr>
+            <a:r>
+              <a:rPr sz="1000" b="0">
+                <a:solidFill>
+                  <a:srgbClr val="6E6E6E"/>
+                </a:solidFill>
+                <a:latin typeface="Arial"/>
+              </a:rPr>
+              <a:t>The two trends the table hides: WFE climbs as the box opens, the floor falls through the 25 mm gate — and the endgame re-solve (stars, next slide) closes both.</a:t>
+            </a:r>
+          </a:p>
+        </p:txBody>
+      </p:sp>
+      <p:sp>
+        <p:nvSpPr>
+          <p:cNvPr id="13" name="TextBox 12"/>
+          <p:cNvSpPr txBox="1"/>
+          <p:nvPr/>
+        </p:nvSpPr>
+        <p:spPr>
+          <a:xfrm>
+            <a:off x="6400800" y="6286500"/>
             <a:ext cx="5394960" cy="274320"/>
           </a:xfrm>
           <a:prstGeom prst="rect">
@@ -7684,115 +8361,13 @@
               </a:spcAft>
             </a:pPr>
             <a:r>
-              <a:rPr sz="1200" b="0">
-                <a:solidFill>
-                  <a:srgbClr val="282828"/>
+              <a:rPr sz="1050" b="0">
+                <a:solidFill>
+                  <a:srgbClr val="6E6E6E"/>
                 </a:solidFill>
                 <a:latin typeface="Arial"/>
               </a:rPr>
-              <a:t>•  Exit PASS at every step — and the last-step clearance residual (17.8 vs 25 mm) CLOSED post-walk: the truer hull model reads the committed design at 28.7 mm (clears as-is), and a restart re-solve in the SAME envelope lands 47.1 nm at a 30.9 mm floor — better than the walk on both axes.  The final step had stopped at 6 iterations on the WFE-only plateau break; clearance was never blocking, just under-solved.</a:t>
-            </a:r>
-          </a:p>
-        </p:txBody>
-      </p:sp>
-      <p:pic>
-        <p:nvPicPr>
-          <p:cNvPr id="7" name="Picture 6" descr="t5_walk_k05_layout.png"/>
-          <p:cNvPicPr>
-            <a:picLocks noChangeAspect="1"/>
-          </p:cNvPicPr>
-          <p:nvPr/>
-        </p:nvPicPr>
-        <p:blipFill>
-          <a:blip r:embed="rId2"/>
-          <a:stretch>
-            <a:fillRect/>
-          </a:stretch>
-        </p:blipFill>
-        <p:spPr>
-          <a:xfrm>
-            <a:off x="8089655" y="4387596"/>
-            <a:ext cx="2017249" cy="1736851"/>
-          </a:xfrm>
-          <a:prstGeom prst="rect">
-            <a:avLst/>
-          </a:prstGeom>
-        </p:spPr>
-      </p:pic>
-      <p:sp>
-        <p:nvSpPr>
-          <p:cNvPr id="8" name="TextBox 7"/>
-          <p:cNvSpPr txBox="1"/>
-          <p:nvPr/>
-        </p:nvSpPr>
-        <p:spPr>
-          <a:xfrm>
-            <a:off x="6400800" y="6142735"/>
-            <a:ext cx="5394960" cy="229107"/>
-          </a:xfrm>
-          <a:prstGeom prst="rect">
-            <a:avLst/>
-          </a:prstGeom>
-          <a:noFill/>
-        </p:spPr>
-        <p:txBody>
-          <a:bodyPr wrap="square">
-            <a:spAutoFit/>
-          </a:bodyPr>
-          <a:lstStyle/>
-          <a:p>
-            <a:pPr algn="ctr">
-              <a:spcAft>
-                <a:spcPts val="0"/>
-              </a:spcAft>
-            </a:pPr>
-            <a:r>
-              <a:rPr sz="1000" b="0">
-                <a:solidFill>
-                  <a:srgbClr val="6E6E6E"/>
-                </a:solidFill>
-                <a:latin typeface="Arial"/>
-              </a:rPr>
-              <a:t>The walked design at the full 15° box: 69.8 nm, floor 17.8 mm.</a:t>
-            </a:r>
-          </a:p>
-        </p:txBody>
-      </p:sp>
-      <p:sp>
-        <p:nvSpPr>
-          <p:cNvPr id="9" name="TextBox 8"/>
-          <p:cNvSpPr txBox="1"/>
-          <p:nvPr/>
-        </p:nvSpPr>
-        <p:spPr>
-          <a:xfrm>
-            <a:off x="6400800" y="6408419"/>
-            <a:ext cx="5394960" cy="274320"/>
-          </a:xfrm>
-          <a:prstGeom prst="rect">
-            <a:avLst/>
-          </a:prstGeom>
-          <a:noFill/>
-        </p:spPr>
-        <p:txBody>
-          <a:bodyPr wrap="square">
-            <a:spAutoFit/>
-          </a:bodyPr>
-          <a:lstStyle/>
-          <a:p>
-            <a:pPr>
-              <a:spcAft>
-                <a:spcPts val="600"/>
-              </a:spcAft>
-            </a:pPr>
-            <a:r>
-              <a:rPr sz="1050" b="0">
-                <a:solidFill>
-                  <a:srgbClr val="6E6E6E"/>
-                </a:solidFill>
-                <a:latin typeface="Arial"/>
-              </a:rPr>
-              <a:t>Records: the t5_redemption / t5_walk / t5_endgame REPORTs (offset_imager template dir); runners oi_walk.m + run_t5_endgame.m.  Every number: the cover contract.</a:t>
+              <a:t>Records: t5_redemption/t5r_REPORT.md + t5_walk/t5_walk_REPORT.md; runner oi_walk.m.  Trend figure: fig_walk_trend.m from the committed .mat records.  Every number: the cover contract.</a:t>
             </a:r>
           </a:p>
         </p:txBody>
@@ -7849,7 +8424,7 @@
                 </a:solidFill>
                 <a:latin typeface="Arial"/>
               </a:rPr>
-              <a:t>F17 — Should mmacos embed an agent helper?</a:t>
+              <a:t>F17 — The endgame: the last gate closes at negative cost</a:t>
             </a:r>
           </a:p>
           <a:p>
@@ -7865,7 +8440,7 @@
                 </a:solidFill>
                 <a:latin typeface="Arial"/>
               </a:rPr>
-              <a:t>The F15/F16 arc feeds both camps — that is the question</a:t>
+              <a:t>Hull reads the walk endpoint at 28.7 mm (clears as-is); the re-solve lands 47.1 nm at 30.9 mm — better than the walk on BOTH axes</a:t>
             </a:r>
           </a:p>
         </p:txBody>
@@ -7948,6 +8523,835 @@
                 </a:solidFill>
                 <a:latin typeface="Arial"/>
               </a:rPr>
+              <a:t>•  WHY the walk left 7.2 mm on the table: oi_solve's plateau break watches WFE only, so the final step stopped at 6 iterations — the moment WFE flattened, with the clearance hinge still pulling.  Under-solved, not blocked.</a:t>
+            </a:r>
+          </a:p>
+          <a:p>
+            <a:pPr>
+              <a:spcAft>
+                <a:spcPts val="600"/>
+              </a:spcAft>
+            </a:pPr>
+            <a:r>
+              <a:rPr sz="1200" b="0">
+                <a:solidFill>
+                  <a:srgbClr val="282828"/>
+                </a:solidFill>
+                <a:latin typeface="Arial"/>
+              </a:rPr>
+              <a:t>•  The re-solve: warm from the 13° step, a restart loop past the break, and the clearance hinge asked for MORE than the gate — at-spec undershoots, because the hinge gradient dies at its own target:</a:t>
+            </a:r>
+          </a:p>
+        </p:txBody>
+      </p:sp>
+      <p:graphicFrame>
+        <p:nvGraphicFramePr>
+          <p:cNvPr id="5" name="Table 4"/>
+          <p:cNvGraphicFramePr>
+            <a:graphicFrameLocks noGrp="1"/>
+          </p:cNvGraphicFramePr>
+          <p:nvPr/>
+        </p:nvGraphicFramePr>
+        <p:xfrm>
+          <a:off x="411480" y="2804160"/>
+          <a:ext cx="5806438" cy="1120140"/>
+        </p:xfrm>
+        <a:graphic>
+          <a:graphicData uri="http://schemas.openxmlformats.org/drawingml/2006/table">
+            <a:tbl>
+              <a:tblPr firstRow="1" bandRow="1">
+                <a:tableStyleId>{5C22544A-7EE6-4342-B048-85BDC9FD1C3A}</a:tableStyleId>
+              </a:tblPr>
+              <a:tblGrid>
+                <a:gridCol w="1055716"/>
+                <a:gridCol w="1266859"/>
+                <a:gridCol w="1055716"/>
+                <a:gridCol w="1689146"/>
+                <a:gridCol w="739001"/>
+              </a:tblGrid>
+              <a:tr h="280035">
+                <a:tc>
+                  <a:txBody>
+                    <a:bodyPr wrap="square"/>
+                    <a:lstStyle/>
+                    <a:p>
+                      <a:r>
+                        <a:rPr sz="1100" b="1">
+                          <a:solidFill>
+                            <a:srgbClr val="FFFFFF"/>
+                          </a:solidFill>
+                          <a:latin typeface="Arial"/>
+                        </a:rPr>
+                        <a:t>hinge (mm)</a:t>
+                      </a:r>
+                    </a:p>
+                  </a:txBody>
+                  <a:tcPr marL="54864" marR="54864" marT="18288" marB="18288">
+                    <a:solidFill>
+                      <a:srgbClr val="1F4E79"/>
+                    </a:solidFill>
+                  </a:tcPr>
+                </a:tc>
+                <a:tc>
+                  <a:txBody>
+                    <a:bodyPr wrap="square"/>
+                    <a:lstStyle/>
+                    <a:p>
+                      <a:r>
+                        <a:rPr sz="1100" b="1">
+                          <a:solidFill>
+                            <a:srgbClr val="FFFFFF"/>
+                          </a:solidFill>
+                          <a:latin typeface="Arial"/>
+                        </a:rPr>
+                        <a:t>map max (nm)</a:t>
+                      </a:r>
+                    </a:p>
+                  </a:txBody>
+                  <a:tcPr marL="54864" marR="54864" marT="18288" marB="18288">
+                    <a:solidFill>
+                      <a:srgbClr val="1F4E79"/>
+                    </a:solidFill>
+                  </a:tcPr>
+                </a:tc>
+                <a:tc>
+                  <a:txBody>
+                    <a:bodyPr wrap="square"/>
+                    <a:lstStyle/>
+                    <a:p>
+                      <a:r>
+                        <a:rPr sz="1100" b="1">
+                          <a:solidFill>
+                            <a:srgbClr val="FFFFFF"/>
+                          </a:solidFill>
+                          <a:latin typeface="Arial"/>
+                        </a:rPr>
+                        <a:t>floor (mm)</a:t>
+                      </a:r>
+                    </a:p>
+                  </a:txBody>
+                  <a:tcPr marL="54864" marR="54864" marT="18288" marB="18288">
+                    <a:solidFill>
+                      <a:srgbClr val="1F4E79"/>
+                    </a:solidFill>
+                  </a:tcPr>
+                </a:tc>
+                <a:tc>
+                  <a:txBody>
+                    <a:bodyPr wrap="square"/>
+                    <a:lstStyle/>
+                    <a:p>
+                      <a:r>
+                        <a:rPr sz="1100" b="1">
+                          <a:solidFill>
+                            <a:srgbClr val="FFFFFF"/>
+                          </a:solidFill>
+                          <a:latin typeface="Arial"/>
+                        </a:rPr>
+                        <a:t>iters / restarts</a:t>
+                      </a:r>
+                    </a:p>
+                  </a:txBody>
+                  <a:tcPr marL="54864" marR="54864" marT="18288" marB="18288">
+                    <a:solidFill>
+                      <a:srgbClr val="1F4E79"/>
+                    </a:solidFill>
+                  </a:tcPr>
+                </a:tc>
+                <a:tc>
+                  <a:txBody>
+                    <a:bodyPr wrap="square"/>
+                    <a:lstStyle/>
+                    <a:p>
+                      <a:r>
+                        <a:rPr sz="1100" b="1">
+                          <a:solidFill>
+                            <a:srgbClr val="FFFFFF"/>
+                          </a:solidFill>
+                          <a:latin typeface="Arial"/>
+                        </a:rPr>
+                        <a:t>≥ 25 mm</a:t>
+                      </a:r>
+                    </a:p>
+                  </a:txBody>
+                  <a:tcPr marL="54864" marR="54864" marT="18288" marB="18288">
+                    <a:solidFill>
+                      <a:srgbClr val="1F4E79"/>
+                    </a:solidFill>
+                  </a:tcPr>
+                </a:tc>
+              </a:tr>
+              <a:tr h="280035">
+                <a:tc>
+                  <a:txBody>
+                    <a:bodyPr wrap="square"/>
+                    <a:lstStyle/>
+                    <a:p>
+                      <a:r>
+                        <a:rPr sz="1100" b="0">
+                          <a:solidFill>
+                            <a:srgbClr val="282828"/>
+                          </a:solidFill>
+                          <a:latin typeface="Arial"/>
+                        </a:rPr>
+                        <a:t>25 (spec)</a:t>
+                      </a:r>
+                    </a:p>
+                  </a:txBody>
+                  <a:tcPr marL="54864" marR="54864" marT="18288" marB="18288">
+                    <a:solidFill>
+                      <a:srgbClr val="FFFFFF"/>
+                    </a:solidFill>
+                  </a:tcPr>
+                </a:tc>
+                <a:tc>
+                  <a:txBody>
+                    <a:bodyPr wrap="square"/>
+                    <a:lstStyle/>
+                    <a:p>
+                      <a:r>
+                        <a:rPr sz="1100" b="0">
+                          <a:solidFill>
+                            <a:srgbClr val="282828"/>
+                          </a:solidFill>
+                          <a:latin typeface="Arial"/>
+                        </a:rPr>
+                        <a:t>51.7</a:t>
+                      </a:r>
+                    </a:p>
+                  </a:txBody>
+                  <a:tcPr marL="54864" marR="54864" marT="18288" marB="18288">
+                    <a:solidFill>
+                      <a:srgbClr val="FFFFFF"/>
+                    </a:solidFill>
+                  </a:tcPr>
+                </a:tc>
+                <a:tc>
+                  <a:txBody>
+                    <a:bodyPr wrap="square"/>
+                    <a:lstStyle/>
+                    <a:p>
+                      <a:r>
+                        <a:rPr sz="1100" b="0">
+                          <a:solidFill>
+                            <a:srgbClr val="282828"/>
+                          </a:solidFill>
+                          <a:latin typeface="Arial"/>
+                        </a:rPr>
+                        <a:t>24.2</a:t>
+                      </a:r>
+                    </a:p>
+                  </a:txBody>
+                  <a:tcPr marL="54864" marR="54864" marT="18288" marB="18288">
+                    <a:solidFill>
+                      <a:srgbClr val="FFFFFF"/>
+                    </a:solidFill>
+                  </a:tcPr>
+                </a:tc>
+                <a:tc>
+                  <a:txBody>
+                    <a:bodyPr wrap="square"/>
+                    <a:lstStyle/>
+                    <a:p>
+                      <a:r>
+                        <a:rPr sz="1100" b="0">
+                          <a:solidFill>
+                            <a:srgbClr val="282828"/>
+                          </a:solidFill>
+                          <a:latin typeface="Arial"/>
+                        </a:rPr>
+                        <a:t>46 / 3</a:t>
+                      </a:r>
+                    </a:p>
+                  </a:txBody>
+                  <a:tcPr marL="54864" marR="54864" marT="18288" marB="18288">
+                    <a:solidFill>
+                      <a:srgbClr val="FFFFFF"/>
+                    </a:solidFill>
+                  </a:tcPr>
+                </a:tc>
+                <a:tc>
+                  <a:txBody>
+                    <a:bodyPr wrap="square"/>
+                    <a:lstStyle/>
+                    <a:p>
+                      <a:r>
+                        <a:rPr sz="1100" b="0">
+                          <a:solidFill>
+                            <a:srgbClr val="282828"/>
+                          </a:solidFill>
+                          <a:latin typeface="Arial"/>
+                        </a:rPr>
+                        <a:t>short</a:t>
+                      </a:r>
+                    </a:p>
+                  </a:txBody>
+                  <a:tcPr marL="54864" marR="54864" marT="18288" marB="18288">
+                    <a:solidFill>
+                      <a:srgbClr val="FFFFFF"/>
+                    </a:solidFill>
+                  </a:tcPr>
+                </a:tc>
+              </a:tr>
+              <a:tr h="280035">
+                <a:tc>
+                  <a:txBody>
+                    <a:bodyPr wrap="square"/>
+                    <a:lstStyle/>
+                    <a:p>
+                      <a:r>
+                        <a:rPr sz="1100" b="0">
+                          <a:solidFill>
+                            <a:srgbClr val="282828"/>
+                          </a:solidFill>
+                          <a:latin typeface="Arial"/>
+                        </a:rPr>
+                        <a:t>32</a:t>
+                      </a:r>
+                    </a:p>
+                  </a:txBody>
+                  <a:tcPr marL="54864" marR="54864" marT="18288" marB="18288">
+                    <a:solidFill>
+                      <a:srgbClr val="ECF1F6"/>
+                    </a:solidFill>
+                  </a:tcPr>
+                </a:tc>
+                <a:tc>
+                  <a:txBody>
+                    <a:bodyPr wrap="square"/>
+                    <a:lstStyle/>
+                    <a:p>
+                      <a:r>
+                        <a:rPr sz="1100" b="0">
+                          <a:solidFill>
+                            <a:srgbClr val="282828"/>
+                          </a:solidFill>
+                          <a:latin typeface="Arial"/>
+                        </a:rPr>
+                        <a:t>47.1</a:t>
+                      </a:r>
+                    </a:p>
+                  </a:txBody>
+                  <a:tcPr marL="54864" marR="54864" marT="18288" marB="18288">
+                    <a:solidFill>
+                      <a:srgbClr val="ECF1F6"/>
+                    </a:solidFill>
+                  </a:tcPr>
+                </a:tc>
+                <a:tc>
+                  <a:txBody>
+                    <a:bodyPr wrap="square"/>
+                    <a:lstStyle/>
+                    <a:p>
+                      <a:r>
+                        <a:rPr sz="1100" b="0">
+                          <a:solidFill>
+                            <a:srgbClr val="282828"/>
+                          </a:solidFill>
+                          <a:latin typeface="Arial"/>
+                        </a:rPr>
+                        <a:t>30.9</a:t>
+                      </a:r>
+                    </a:p>
+                  </a:txBody>
+                  <a:tcPr marL="54864" marR="54864" marT="18288" marB="18288">
+                    <a:solidFill>
+                      <a:srgbClr val="ECF1F6"/>
+                    </a:solidFill>
+                  </a:tcPr>
+                </a:tc>
+                <a:tc>
+                  <a:txBody>
+                    <a:bodyPr wrap="square"/>
+                    <a:lstStyle/>
+                    <a:p>
+                      <a:r>
+                        <a:rPr sz="1100" b="0">
+                          <a:solidFill>
+                            <a:srgbClr val="282828"/>
+                          </a:solidFill>
+                          <a:latin typeface="Arial"/>
+                        </a:rPr>
+                        <a:t>82 / 5</a:t>
+                      </a:r>
+                    </a:p>
+                  </a:txBody>
+                  <a:tcPr marL="54864" marR="54864" marT="18288" marB="18288">
+                    <a:solidFill>
+                      <a:srgbClr val="ECF1F6"/>
+                    </a:solidFill>
+                  </a:tcPr>
+                </a:tc>
+                <a:tc>
+                  <a:txBody>
+                    <a:bodyPr wrap="square"/>
+                    <a:lstStyle/>
+                    <a:p>
+                      <a:r>
+                        <a:rPr sz="1100" b="0">
+                          <a:solidFill>
+                            <a:srgbClr val="282828"/>
+                          </a:solidFill>
+                          <a:latin typeface="Arial"/>
+                        </a:rPr>
+                        <a:t>yes</a:t>
+                      </a:r>
+                    </a:p>
+                  </a:txBody>
+                  <a:tcPr marL="54864" marR="54864" marT="18288" marB="18288">
+                    <a:solidFill>
+                      <a:srgbClr val="ECF1F6"/>
+                    </a:solidFill>
+                  </a:tcPr>
+                </a:tc>
+              </a:tr>
+              <a:tr h="280035">
+                <a:tc>
+                  <a:txBody>
+                    <a:bodyPr wrap="square"/>
+                    <a:lstStyle/>
+                    <a:p>
+                      <a:r>
+                        <a:rPr sz="1100" b="0">
+                          <a:solidFill>
+                            <a:srgbClr val="282828"/>
+                          </a:solidFill>
+                          <a:latin typeface="Arial"/>
+                        </a:rPr>
+                        <a:t>40</a:t>
+                      </a:r>
+                    </a:p>
+                  </a:txBody>
+                  <a:tcPr marL="54864" marR="54864" marT="18288" marB="18288">
+                    <a:solidFill>
+                      <a:srgbClr val="FFFFFF"/>
+                    </a:solidFill>
+                  </a:tcPr>
+                </a:tc>
+                <a:tc>
+                  <a:txBody>
+                    <a:bodyPr wrap="square"/>
+                    <a:lstStyle/>
+                    <a:p>
+                      <a:r>
+                        <a:rPr sz="1100" b="0">
+                          <a:solidFill>
+                            <a:srgbClr val="282828"/>
+                          </a:solidFill>
+                          <a:latin typeface="Arial"/>
+                        </a:rPr>
+                        <a:t>47.3</a:t>
+                      </a:r>
+                    </a:p>
+                  </a:txBody>
+                  <a:tcPr marL="54864" marR="54864" marT="18288" marB="18288">
+                    <a:solidFill>
+                      <a:srgbClr val="FFFFFF"/>
+                    </a:solidFill>
+                  </a:tcPr>
+                </a:tc>
+                <a:tc>
+                  <a:txBody>
+                    <a:bodyPr wrap="square"/>
+                    <a:lstStyle/>
+                    <a:p>
+                      <a:r>
+                        <a:rPr sz="1100" b="0">
+                          <a:solidFill>
+                            <a:srgbClr val="282828"/>
+                          </a:solidFill>
+                          <a:latin typeface="Arial"/>
+                        </a:rPr>
+                        <a:t>39.0</a:t>
+                      </a:r>
+                    </a:p>
+                  </a:txBody>
+                  <a:tcPr marL="54864" marR="54864" marT="18288" marB="18288">
+                    <a:solidFill>
+                      <a:srgbClr val="FFFFFF"/>
+                    </a:solidFill>
+                  </a:tcPr>
+                </a:tc>
+                <a:tc>
+                  <a:txBody>
+                    <a:bodyPr wrap="square"/>
+                    <a:lstStyle/>
+                    <a:p>
+                      <a:r>
+                        <a:rPr sz="1100" b="0">
+                          <a:solidFill>
+                            <a:srgbClr val="282828"/>
+                          </a:solidFill>
+                          <a:latin typeface="Arial"/>
+                        </a:rPr>
+                        <a:t>92 / 6</a:t>
+                      </a:r>
+                    </a:p>
+                  </a:txBody>
+                  <a:tcPr marL="54864" marR="54864" marT="18288" marB="18288">
+                    <a:solidFill>
+                      <a:srgbClr val="FFFFFF"/>
+                    </a:solidFill>
+                  </a:tcPr>
+                </a:tc>
+                <a:tc>
+                  <a:txBody>
+                    <a:bodyPr wrap="square"/>
+                    <a:lstStyle/>
+                    <a:p>
+                      <a:r>
+                        <a:rPr sz="1100" b="0">
+                          <a:solidFill>
+                            <a:srgbClr val="282828"/>
+                          </a:solidFill>
+                          <a:latin typeface="Arial"/>
+                        </a:rPr>
+                        <a:t>yes</a:t>
+                      </a:r>
+                    </a:p>
+                  </a:txBody>
+                  <a:tcPr marL="54864" marR="54864" marT="18288" marB="18288">
+                    <a:solidFill>
+                      <a:srgbClr val="FFFFFF"/>
+                    </a:solidFill>
+                  </a:tcPr>
+                </a:tc>
+              </a:tr>
+            </a:tbl>
+          </a:graphicData>
+        </a:graphic>
+      </p:graphicFrame>
+      <p:sp>
+        <p:nvSpPr>
+          <p:cNvPr id="6" name="TextBox 5"/>
+          <p:cNvSpPr txBox="1"/>
+          <p:nvPr/>
+        </p:nvSpPr>
+        <p:spPr>
+          <a:xfrm>
+            <a:off x="411480" y="4070603"/>
+            <a:ext cx="5806440" cy="274320"/>
+          </a:xfrm>
+          <a:prstGeom prst="rect">
+            <a:avLst/>
+          </a:prstGeom>
+          <a:noFill/>
+        </p:spPr>
+        <p:txBody>
+          <a:bodyPr wrap="square">
+            <a:spAutoFit/>
+          </a:bodyPr>
+          <a:lstStyle/>
+          <a:p>
+            <a:pPr>
+              <a:spcAft>
+                <a:spcPts val="600"/>
+              </a:spcAft>
+            </a:pPr>
+            <a:r>
+              <a:rPr sz="1200" b="0">
+                <a:solidFill>
+                  <a:srgbClr val="282828"/>
+                </a:solidFill>
+                <a:latin typeface="Arial"/>
+              </a:rPr>
+              <a:t>•  Envelope stretch is the WRONG lever: x1.75–x1.9 buys WFE (34.9 -&gt; 31.3 nm) while the at-spec floor asymptotes just under 25 mm — and the x1.65 envelope already reaches 30.9.  Keep the envelope; raise the hinge.</a:t>
+            </a:r>
+          </a:p>
+        </p:txBody>
+      </p:sp>
+      <p:pic>
+        <p:nvPicPr>
+          <p:cNvPr id="7" name="Picture 6" descr="t5_endgame_wfe_map.png"/>
+          <p:cNvPicPr>
+            <a:picLocks noChangeAspect="1"/>
+          </p:cNvPicPr>
+          <p:nvPr/>
+        </p:nvPicPr>
+        <p:blipFill>
+          <a:blip r:embed="rId2"/>
+          <a:stretch>
+            <a:fillRect/>
+          </a:stretch>
+        </p:blipFill>
+        <p:spPr>
+          <a:xfrm>
+            <a:off x="7581375" y="1298448"/>
+            <a:ext cx="3033808" cy="2669032"/>
+          </a:xfrm>
+          <a:prstGeom prst="rect">
+            <a:avLst/>
+          </a:prstGeom>
+        </p:spPr>
+      </p:pic>
+      <p:sp>
+        <p:nvSpPr>
+          <p:cNvPr id="8" name="TextBox 7"/>
+          <p:cNvSpPr txBox="1"/>
+          <p:nvPr/>
+        </p:nvSpPr>
+        <p:spPr>
+          <a:xfrm>
+            <a:off x="6400800" y="3985767"/>
+            <a:ext cx="5394960" cy="394208"/>
+          </a:xfrm>
+          <a:prstGeom prst="rect">
+            <a:avLst/>
+          </a:prstGeom>
+          <a:noFill/>
+        </p:spPr>
+        <p:txBody>
+          <a:bodyPr wrap="square">
+            <a:spAutoFit/>
+          </a:bodyPr>
+          <a:lstStyle/>
+          <a:p>
+            <a:pPr algn="ctr">
+              <a:spcAft>
+                <a:spcPts val="0"/>
+              </a:spcAft>
+            </a:pPr>
+            <a:r>
+              <a:rPr sz="1000" b="0">
+                <a:solidFill>
+                  <a:srgbClr val="6E6E6E"/>
+                </a:solidFill>
+                <a:latin typeface="Arial"/>
+              </a:rPr>
+              <a:t>The closing map, ladder-style: 47.1 nm max over the 15° box at a 30.9 mm floor (deck t5_endgame_wfe.in, committed).</a:t>
+            </a:r>
+          </a:p>
+        </p:txBody>
+      </p:sp>
+      <p:sp>
+        <p:nvSpPr>
+          <p:cNvPr id="9" name="TextBox 8"/>
+          <p:cNvSpPr txBox="1"/>
+          <p:nvPr/>
+        </p:nvSpPr>
+        <p:spPr>
+          <a:xfrm>
+            <a:off x="6400800" y="4416552"/>
+            <a:ext cx="5394960" cy="274320"/>
+          </a:xfrm>
+          <a:prstGeom prst="rect">
+            <a:avLst/>
+          </a:prstGeom>
+          <a:noFill/>
+        </p:spPr>
+        <p:txBody>
+          <a:bodyPr wrap="square">
+            <a:spAutoFit/>
+          </a:bodyPr>
+          <a:lstStyle/>
+          <a:p>
+            <a:pPr>
+              <a:spcAft>
+                <a:spcPts val="600"/>
+              </a:spcAft>
+            </a:pPr>
+            <a:r>
+              <a:rPr sz="1200" b="0">
+                <a:solidFill>
+                  <a:srgbClr val="282828"/>
+                </a:solidFill>
+                <a:latin typeface="Arial"/>
+              </a:rPr>
+              <a:t>•  Every frontier box is now spec-compliant: the deficit was part model conservatism (hull 28.7 mm), part under-solve — and zero physics.</a:t>
+            </a:r>
+          </a:p>
+        </p:txBody>
+      </p:sp>
+      <p:sp>
+        <p:nvSpPr>
+          <p:cNvPr id="10" name="TextBox 9"/>
+          <p:cNvSpPr txBox="1"/>
+          <p:nvPr/>
+        </p:nvSpPr>
+        <p:spPr>
+          <a:xfrm>
+            <a:off x="6400800" y="4989576"/>
+            <a:ext cx="5394960" cy="274320"/>
+          </a:xfrm>
+          <a:prstGeom prst="rect">
+            <a:avLst/>
+          </a:prstGeom>
+          <a:noFill/>
+        </p:spPr>
+        <p:txBody>
+          <a:bodyPr wrap="square">
+            <a:spAutoFit/>
+          </a:bodyPr>
+          <a:lstStyle/>
+          <a:p>
+            <a:pPr>
+              <a:spcAft>
+                <a:spcPts val="600"/>
+              </a:spcAft>
+            </a:pPr>
+            <a:r>
+              <a:rPr sz="1050" b="0">
+                <a:solidFill>
+                  <a:srgbClr val="6E6E6E"/>
+                </a:solidFill>
+                <a:latin typeface="Arial"/>
+              </a:rPr>
+              <a:t>Record: t5_endgame/t5_endgame_REPORT.md (verdict CLOSED); harness run_t5_endgame.m — CCMac's runs, cross-checked on Linux to 4.6e-13 mm.  Every number: the cover contract.</a:t>
+            </a:r>
+          </a:p>
+        </p:txBody>
+      </p:sp>
+    </p:spTree>
+  </p:cSld>
+  <p:clrMapOvr>
+    <a:masterClrMapping/>
+  </p:clrMapOvr>
+</p:sld>
+</file>
+
+<file path=ppt/slides/slide19.xml><?xml version="1.0" encoding="utf-8"?>
+<p:sld xmlns:a="http://schemas.openxmlformats.org/drawingml/2006/main" xmlns:p="http://schemas.openxmlformats.org/presentationml/2006/main" xmlns:r="http://schemas.openxmlformats.org/officeDocument/2006/relationships">
+  <p:cSld>
+    <p:spTree>
+      <p:nvGrpSpPr>
+        <p:cNvPr id="1" name=""/>
+        <p:cNvGrpSpPr/>
+        <p:nvPr/>
+      </p:nvGrpSpPr>
+      <p:grpSpPr/>
+      <p:sp>
+        <p:nvSpPr>
+          <p:cNvPr id="2" name="TextBox 1"/>
+          <p:cNvSpPr txBox="1"/>
+          <p:nvPr/>
+        </p:nvSpPr>
+        <p:spPr>
+          <a:xfrm>
+            <a:off x="411480" y="201168"/>
+            <a:ext cx="11368735" cy="914400"/>
+          </a:xfrm>
+          <a:prstGeom prst="rect">
+            <a:avLst/>
+          </a:prstGeom>
+          <a:noFill/>
+        </p:spPr>
+        <p:txBody>
+          <a:bodyPr wrap="square">
+            <a:spAutoFit/>
+          </a:bodyPr>
+          <a:lstStyle/>
+          <a:p>
+            <a:pPr>
+              <a:spcAft>
+                <a:spcPts val="400"/>
+              </a:spcAft>
+            </a:pPr>
+            <a:r>
+              <a:rPr sz="2400" b="1">
+                <a:solidFill>
+                  <a:srgbClr val="1F4E79"/>
+                </a:solidFill>
+                <a:latin typeface="Arial"/>
+              </a:rPr>
+              <a:t>F18 — Should mmacos embed an agent helper?</a:t>
+            </a:r>
+          </a:p>
+          <a:p>
+            <a:pPr>
+              <a:spcAft>
+                <a:spcPts val="0"/>
+              </a:spcAft>
+            </a:pPr>
+            <a:r>
+              <a:rPr sz="1250" b="0">
+                <a:solidFill>
+                  <a:srgbClr val="6E6E6E"/>
+                </a:solidFill>
+                <a:latin typeface="Arial"/>
+              </a:rPr>
+              <a:t>The F15–F17 arc feeds both camps — that is the question</a:t>
+            </a:r>
+          </a:p>
+        </p:txBody>
+      </p:sp>
+      <p:sp>
+        <p:nvSpPr>
+          <p:cNvPr id="3" name="Rectangle 2"/>
+          <p:cNvSpPr/>
+          <p:nvPr/>
+        </p:nvSpPr>
+        <p:spPr>
+          <a:xfrm>
+            <a:off x="411480" y="1133856"/>
+            <a:ext cx="11368735" cy="20320"/>
+          </a:xfrm>
+          <a:prstGeom prst="rect">
+            <a:avLst/>
+          </a:prstGeom>
+          <a:solidFill>
+            <a:srgbClr val="B8C6D4"/>
+          </a:solidFill>
+          <a:ln>
+            <a:noFill/>
+          </a:ln>
+          <a:effectLst/>
+        </p:spPr>
+        <p:style>
+          <a:lnRef idx="1">
+            <a:schemeClr val="accent1"/>
+          </a:lnRef>
+          <a:fillRef idx="3">
+            <a:schemeClr val="accent1"/>
+          </a:fillRef>
+          <a:effectRef idx="2">
+            <a:schemeClr val="accent1"/>
+          </a:effectRef>
+          <a:fontRef idx="minor">
+            <a:schemeClr val="lt1"/>
+          </a:fontRef>
+        </p:style>
+        <p:txBody>
+          <a:bodyPr rtlCol="0" anchor="ctr"/>
+          <a:lstStyle/>
+          <a:p>
+            <a:pPr algn="ctr"/>
+          </a:p>
+        </p:txBody>
+      </p:sp>
+      <p:sp>
+        <p:nvSpPr>
+          <p:cNvPr id="4" name="TextBox 3"/>
+          <p:cNvSpPr txBox="1"/>
+          <p:nvPr/>
+        </p:nvSpPr>
+        <p:spPr>
+          <a:xfrm>
+            <a:off x="411480" y="1298448"/>
+            <a:ext cx="5806440" cy="274320"/>
+          </a:xfrm>
+          <a:prstGeom prst="rect">
+            <a:avLst/>
+          </a:prstGeom>
+          <a:noFill/>
+        </p:spPr>
+        <p:txBody>
+          <a:bodyPr wrap="square">
+            <a:spAutoFit/>
+          </a:bodyPr>
+          <a:lstStyle/>
+          <a:p>
+            <a:pPr>
+              <a:spcAft>
+                <a:spcPts val="600"/>
+              </a:spcAft>
+            </a:pPr>
+            <a:r>
+              <a:rPr sz="1200" b="0">
+                <a:solidFill>
+                  <a:srgbClr val="282828"/>
+                </a:solidFill>
+                <a:latin typeface="Arial"/>
+              </a:rPr>
               <a:t>•  FOR, from this arc: every defect found was a CONCEPTUAL coupling — a frame convention, a metric reference, a constraint model — that documentation had not prevented; agent-in-the-loop found and fixed each in hours.  And F15's one conceptual failure (S1 depth poisoning offset traceability) was DOCUMENTED and still not actionable — the case for advice AT CALL TIME ("your S1 is 8x deeper than the reference; expect the offset box to lose rays").</a:t>
             </a:r>
           </a:p>
@@ -7980,7 +9384,7 @@
                 </a:solidFill>
                 <a:latin typeface="Arial"/>
               </a:rPr>
-              <a:t>•  The F16 sequel is itself an AGAINST exhibit: the continuation STRATEGY — agreed in one discussion — compiled into a runner (oi_walk.m), and the compiled walk then solved unattended the instance the cold start could not.  The walk itself is compiled knowledge.</a:t>
+              <a:t>•  The F16–F17 sequel is itself an AGAINST exhibit: the continuation STRATEGY — agreed in one discussion — compiled into a runner (oi_walk.m), the compiled walk solved unattended the instance the cold start could not, and the endgame close came from the same loop (run_t5_endgame.m).  The walk itself is compiled knowledge.</a:t>
             </a:r>
           </a:p>
         </p:txBody>
@@ -8106,7 +9510,7 @@
                 </a:solidFill>
                 <a:latin typeface="Arial"/>
               </a:rPr>
-              <a:t>Discussion slide: questions are the deliverable.  The measured input: docs + gates did NOT carry an unassisted user through a COLD re-instance (F15); the compiled walk then did (F16) — most of the gap was compilable, and was compiled.</a:t>
+              <a:t>Discussion slide: questions are the deliverable.  The measured input: docs + gates did NOT carry an unassisted user through a COLD re-instance (F15); the compiled walk then did (F16–F17) — most of the gap was compilable, and was compiled.</a:t>
             </a:r>
           </a:p>
         </p:txBody>

</xml_diff>